<commit_message>
Document the improvement journey (process log + figure + process slide)
JOURNEY.md: per-dimension start / tried (incl. rejected attempts) / landed, all measured.
Adds scripts/improvement_journey.py and the figure; inserts a Process slide in the deck.

Co-Authored-By: Claude Opus 4.8 <noreply@anthropic.com>
</commit_message>
<xml_diff>
--- a/reports/ISAF_Recidivism_Presentation.pptx
+++ b/reports/ISAF_Recidivism_Presentation.pptx
@@ -20,6 +20,7 @@
     <p:sldId id="268" r:id="rId19"/>
     <p:sldId id="269" r:id="rId20"/>
     <p:sldId id="270" r:id="rId21"/>
+    <p:sldId id="271" r:id="rId22"/>
   </p:sldIdLst>
   <p:sldSz cx="12191695" cy="6858000" type="screen4x3"/>
   <p:notesSz cx="6858000" cy="9144000"/>
@@ -5048,7 +5049,7 @@
               </a:defRPr>
             </a:pPr>
             <a:r>
-              <a:t>12 · TRADE-OFFS ACROSS FOUR DIMENSIONS</a:t>
+              <a:t>12 · PROCESS</a:t>
             </a:r>
           </a:p>
         </p:txBody>
@@ -5084,7 +5085,7 @@
               </a:defRPr>
             </a:pPr>
             <a:r>
-              <a:t>Which model should the client deploy?</a:t>
+              <a:t>How we got here: what we tried, where we landed</a:t>
             </a:r>
           </a:p>
         </p:txBody>
@@ -5134,7 +5135,7 @@
       </p:sp>
       <p:pic>
         <p:nvPicPr>
-          <p:cNvPr id="5" name="Picture 4" descr="tradeoff_matrix.png"/>
+          <p:cNvPr id="5" name="Picture 4" descr="improvement_journey.png"/>
           <p:cNvPicPr>
             <a:picLocks noChangeAspect="1"/>
           </p:cNvPicPr>
@@ -5148,8 +5149,8 @@
         </p:blipFill>
         <p:spPr>
           <a:xfrm>
-            <a:off x="2011680" y="1481328"/>
-            <a:ext cx="8138160" cy="6081764"/>
+            <a:off x="502920" y="1600200"/>
+            <a:ext cx="11155680" cy="4049941"/>
           </a:xfrm>
           <a:prstGeom prst="rect">
             <a:avLst/>
@@ -5159,6 +5160,42 @@
       <p:sp>
         <p:nvSpPr>
           <p:cNvPr id="6" name="TextBox 5"/>
+          <p:cNvSpPr txBox="1"/>
+          <p:nvPr/>
+        </p:nvSpPr>
+        <p:spPr>
+          <a:xfrm>
+            <a:off x="914400" y="6236208"/>
+            <a:ext cx="10058400" cy="274320"/>
+          </a:xfrm>
+          <a:prstGeom prst="rect">
+            <a:avLst/>
+          </a:prstGeom>
+          <a:noFill/>
+        </p:spPr>
+        <p:txBody>
+          <a:bodyPr wrap="square" anchor="t">
+            <a:spAutoFit/>
+          </a:bodyPr>
+          <a:lstStyle/>
+          <a:p>
+            <a:pPr algn="ctr">
+              <a:defRPr sz="1100" b="1">
+                <a:solidFill>
+                  <a:srgbClr val="FB8500"/>
+                </a:solidFill>
+                <a:latin typeface="Aptos"/>
+              </a:defRPr>
+            </a:pPr>
+            <a:r>
+              <a:t>Full log in JOURNEY.md — every step measured, including the attempts we rejected.</a:t>
+            </a:r>
+          </a:p>
+        </p:txBody>
+      </p:sp>
+      <p:sp>
+        <p:nvSpPr>
+          <p:cNvPr id="7" name="TextBox 6"/>
           <p:cNvSpPr txBox="1"/>
           <p:nvPr/>
         </p:nvSpPr>
@@ -5194,7 +5231,7 @@
       </p:sp>
       <p:sp>
         <p:nvSpPr>
-          <p:cNvPr id="7" name="TextBox 6"/>
+          <p:cNvPr id="8" name="TextBox 7"/>
           <p:cNvSpPr txBox="1"/>
           <p:nvPr/>
         </p:nvSpPr>
@@ -5285,7 +5322,7 @@
               </a:defRPr>
             </a:pPr>
             <a:r>
-              <a:t>13 · RECOMMENDATION</a:t>
+              <a:t>13 · TRADE-OFFS ACROSS FOUR DIMENSIONS</a:t>
             </a:r>
           </a:p>
         </p:txBody>
@@ -5321,7 +5358,7 @@
               </a:defRPr>
             </a:pPr>
             <a:r>
-              <a:t>Deploy XGBoost; challenger logistic; TabICL for small agencies</a:t>
+              <a:t>Which model should the client deploy?</a:t>
             </a:r>
           </a:p>
         </p:txBody>
@@ -5369,273 +5406,33 @@
           </a:p>
         </p:txBody>
       </p:sp>
-      <p:sp>
-        <p:nvSpPr>
-          <p:cNvPr id="5" name="Rounded Rectangle 4"/>
-          <p:cNvSpPr/>
-          <p:nvPr/>
-        </p:nvSpPr>
-        <p:spPr>
-          <a:xfrm>
-            <a:off x="731520" y="1645920"/>
-            <a:ext cx="5257800" cy="4251960"/>
-          </a:xfrm>
-          <a:prstGeom prst="roundRect">
-            <a:avLst/>
-          </a:prstGeom>
-          <a:solidFill>
-            <a:srgbClr val="143058"/>
-          </a:solidFill>
-          <a:ln>
-            <a:solidFill>
-              <a:srgbClr val="00B4B4"/>
-            </a:solidFill>
-          </a:ln>
-        </p:spPr>
-        <p:style>
-          <a:lnRef idx="1">
-            <a:schemeClr val="accent1"/>
-          </a:lnRef>
-          <a:fillRef idx="3">
-            <a:schemeClr val="accent1"/>
-          </a:fillRef>
-          <a:effectRef idx="2">
-            <a:schemeClr val="accent1"/>
-          </a:effectRef>
-          <a:fontRef idx="minor">
-            <a:schemeClr val="lt1"/>
-          </a:fontRef>
-        </p:style>
-        <p:txBody>
-          <a:bodyPr rtlCol="0" anchor="ctr"/>
-          <a:lstStyle/>
-          <a:p>
-            <a:pPr algn="ctr"/>
-          </a:p>
-        </p:txBody>
-      </p:sp>
+      <p:pic>
+        <p:nvPicPr>
+          <p:cNvPr id="5" name="Picture 4" descr="tradeoff_matrix.png"/>
+          <p:cNvPicPr>
+            <a:picLocks noChangeAspect="1"/>
+          </p:cNvPicPr>
+          <p:nvPr/>
+        </p:nvPicPr>
+        <p:blipFill>
+          <a:blip r:embed="rId2"/>
+          <a:stretch>
+            <a:fillRect/>
+          </a:stretch>
+        </p:blipFill>
+        <p:spPr>
+          <a:xfrm>
+            <a:off x="2011680" y="1481328"/>
+            <a:ext cx="8138160" cy="6081764"/>
+          </a:xfrm>
+          <a:prstGeom prst="rect">
+            <a:avLst/>
+          </a:prstGeom>
+        </p:spPr>
+      </p:pic>
       <p:sp>
         <p:nvSpPr>
           <p:cNvPr id="6" name="TextBox 5"/>
-          <p:cNvSpPr txBox="1"/>
-          <p:nvPr/>
-        </p:nvSpPr>
-        <p:spPr>
-          <a:xfrm>
-            <a:off x="960120" y="1920240"/>
-            <a:ext cx="4800600" cy="365760"/>
-          </a:xfrm>
-          <a:prstGeom prst="rect">
-            <a:avLst/>
-          </a:prstGeom>
-          <a:noFill/>
-        </p:spPr>
-        <p:txBody>
-          <a:bodyPr wrap="square" anchor="t">
-            <a:spAutoFit/>
-          </a:bodyPr>
-          <a:lstStyle/>
-          <a:p>
-            <a:pPr algn="ctr">
-              <a:defRPr sz="2000" b="1">
-                <a:solidFill>
-                  <a:srgbClr val="00B4B4"/>
-                </a:solidFill>
-                <a:latin typeface="Aptos"/>
-              </a:defRPr>
-            </a:pPr>
-            <a:r>
-              <a:t>WHY XGBOOST</a:t>
-            </a:r>
-          </a:p>
-        </p:txBody>
-      </p:sp>
-      <p:sp>
-        <p:nvSpPr>
-          <p:cNvPr id="7" name="TextBox 6"/>
-          <p:cNvSpPr txBox="1"/>
-          <p:nvPr/>
-        </p:nvSpPr>
-        <p:spPr>
-          <a:xfrm>
-            <a:off x="1051560" y="2633472"/>
-            <a:ext cx="4617720" cy="3017520"/>
-          </a:xfrm>
-          <a:prstGeom prst="rect">
-            <a:avLst/>
-          </a:prstGeom>
-          <a:noFill/>
-        </p:spPr>
-        <p:txBody>
-          <a:bodyPr wrap="square" anchor="t">
-            <a:spAutoFit/>
-          </a:bodyPr>
-          <a:lstStyle/>
-          <a:p>
-            <a:pPr algn="ctr">
-              <a:defRPr sz="1500" b="0">
-                <a:solidFill>
-                  <a:srgbClr val="F0F4F8"/>
-                </a:solidFill>
-                <a:latin typeface="Aptos"/>
-              </a:defRPr>
-            </a:pPr>
-            <a:r>
-              <a:t>Best calibration + net value</a:t>
-            </a:r>
-            <a:br/>
-            <a:br/>
-            <a:r>
-              <a:t>Smallest gender FPR gap</a:t>
-            </a:r>
-            <a:br/>
-            <a:br/>
-            <a:r>
-              <a:t>SHAP-explainable</a:t>
-            </a:r>
-            <a:br/>
-            <a:br/>
-            <a:r>
-              <a:t>35× faster than the TFM</a:t>
-            </a:r>
-          </a:p>
-        </p:txBody>
-      </p:sp>
-      <p:sp>
-        <p:nvSpPr>
-          <p:cNvPr id="8" name="Rounded Rectangle 7"/>
-          <p:cNvSpPr/>
-          <p:nvPr/>
-        </p:nvSpPr>
-        <p:spPr>
-          <a:xfrm>
-            <a:off x="6217920" y="1645920"/>
-            <a:ext cx="5257800" cy="4251960"/>
-          </a:xfrm>
-          <a:prstGeom prst="roundRect">
-            <a:avLst/>
-          </a:prstGeom>
-          <a:solidFill>
-            <a:srgbClr val="143058"/>
-          </a:solidFill>
-          <a:ln>
-            <a:solidFill>
-              <a:srgbClr val="7B2CBF"/>
-            </a:solidFill>
-          </a:ln>
-        </p:spPr>
-        <p:style>
-          <a:lnRef idx="1">
-            <a:schemeClr val="accent1"/>
-          </a:lnRef>
-          <a:fillRef idx="3">
-            <a:schemeClr val="accent1"/>
-          </a:fillRef>
-          <a:effectRef idx="2">
-            <a:schemeClr val="accent1"/>
-          </a:effectRef>
-          <a:fontRef idx="minor">
-            <a:schemeClr val="lt1"/>
-          </a:fontRef>
-        </p:style>
-        <p:txBody>
-          <a:bodyPr rtlCol="0" anchor="ctr"/>
-          <a:lstStyle/>
-          <a:p>
-            <a:pPr algn="ctr"/>
-          </a:p>
-        </p:txBody>
-      </p:sp>
-      <p:sp>
-        <p:nvSpPr>
-          <p:cNvPr id="9" name="TextBox 8"/>
-          <p:cNvSpPr txBox="1"/>
-          <p:nvPr/>
-        </p:nvSpPr>
-        <p:spPr>
-          <a:xfrm>
-            <a:off x="6446520" y="1920240"/>
-            <a:ext cx="4800600" cy="365760"/>
-          </a:xfrm>
-          <a:prstGeom prst="rect">
-            <a:avLst/>
-          </a:prstGeom>
-          <a:noFill/>
-        </p:spPr>
-        <p:txBody>
-          <a:bodyPr wrap="square" anchor="t">
-            <a:spAutoFit/>
-          </a:bodyPr>
-          <a:lstStyle/>
-          <a:p>
-            <a:pPr algn="ctr">
-              <a:defRPr sz="2000" b="1">
-                <a:solidFill>
-                  <a:srgbClr val="7B2CBF"/>
-                </a:solidFill>
-                <a:latin typeface="Aptos"/>
-              </a:defRPr>
-            </a:pPr>
-            <a:r>
-              <a:t>CONDITIONS</a:t>
-            </a:r>
-          </a:p>
-        </p:txBody>
-      </p:sp>
-      <p:sp>
-        <p:nvSpPr>
-          <p:cNvPr id="10" name="TextBox 9"/>
-          <p:cNvSpPr txBox="1"/>
-          <p:nvPr/>
-        </p:nvSpPr>
-        <p:spPr>
-          <a:xfrm>
-            <a:off x="6537959" y="2633472"/>
-            <a:ext cx="4617720" cy="3017520"/>
-          </a:xfrm>
-          <a:prstGeom prst="rect">
-            <a:avLst/>
-          </a:prstGeom>
-          <a:noFill/>
-        </p:spPr>
-        <p:txBody>
-          <a:bodyPr wrap="square" anchor="t">
-            <a:spAutoFit/>
-          </a:bodyPr>
-          <a:lstStyle/>
-          <a:p>
-            <a:pPr algn="ctr">
-              <a:defRPr sz="1500" b="0">
-                <a:solidFill>
-                  <a:srgbClr val="F0F4F8"/>
-                </a:solidFill>
-                <a:latin typeface="Aptos"/>
-              </a:defRPr>
-            </a:pPr>
-            <a:r>
-              <a:t>Benefit-only allocation</a:t>
-            </a:r>
-            <a:br/>
-            <a:br/>
-            <a:r>
-              <a:t>Logistic as transparent challenger</a:t>
-            </a:r>
-            <a:br/>
-            <a:br/>
-            <a:r>
-              <a:t>Prospective shadow validation</a:t>
-            </a:r>
-            <a:br/>
-            <a:br/>
-            <a:r>
-              <a:t>Appeal route, logs, quarterly audits, stop rules</a:t>
-            </a:r>
-          </a:p>
-        </p:txBody>
-      </p:sp>
-      <p:sp>
-        <p:nvSpPr>
-          <p:cNvPr id="11" name="TextBox 10"/>
           <p:cNvSpPr txBox="1"/>
           <p:nvPr/>
         </p:nvSpPr>
@@ -5671,7 +5468,7 @@
       </p:sp>
       <p:sp>
         <p:nvSpPr>
-          <p:cNvPr id="12" name="TextBox 11"/>
+          <p:cNvPr id="7" name="TextBox 6"/>
           <p:cNvSpPr txBox="1"/>
           <p:nvPr/>
         </p:nvSpPr>
@@ -5762,7 +5559,484 @@
               </a:defRPr>
             </a:pPr>
             <a:r>
-              <a:t>14 · CLIENT EXPERIENCE</a:t>
+              <a:t>14 · RECOMMENDATION</a:t>
+            </a:r>
+          </a:p>
+        </p:txBody>
+      </p:sp>
+      <p:sp>
+        <p:nvSpPr>
+          <p:cNvPr id="3" name="TextBox 2"/>
+          <p:cNvSpPr txBox="1"/>
+          <p:nvPr/>
+        </p:nvSpPr>
+        <p:spPr>
+          <a:xfrm>
+            <a:off x="594360" y="621792"/>
+            <a:ext cx="10972800" cy="594360"/>
+          </a:xfrm>
+          <a:prstGeom prst="rect">
+            <a:avLst/>
+          </a:prstGeom>
+          <a:noFill/>
+        </p:spPr>
+        <p:txBody>
+          <a:bodyPr wrap="square" anchor="t">
+            <a:spAutoFit/>
+          </a:bodyPr>
+          <a:lstStyle/>
+          <a:p>
+            <a:pPr algn="l">
+              <a:defRPr sz="2600" b="1">
+                <a:solidFill>
+                  <a:srgbClr val="FFFFFF"/>
+                </a:solidFill>
+                <a:latin typeface="Aptos"/>
+              </a:defRPr>
+            </a:pPr>
+            <a:r>
+              <a:t>Deploy XGBoost; challenger logistic; TabICL for small agencies</a:t>
+            </a:r>
+          </a:p>
+        </p:txBody>
+      </p:sp>
+      <p:sp>
+        <p:nvSpPr>
+          <p:cNvPr id="4" name="Rectangle 3"/>
+          <p:cNvSpPr/>
+          <p:nvPr/>
+        </p:nvSpPr>
+        <p:spPr>
+          <a:xfrm>
+            <a:off x="594360" y="1298448"/>
+            <a:ext cx="1005840" cy="50292"/>
+          </a:xfrm>
+          <a:prstGeom prst="rect">
+            <a:avLst/>
+          </a:prstGeom>
+          <a:solidFill>
+            <a:srgbClr val="FB8500"/>
+          </a:solidFill>
+          <a:ln>
+            <a:noFill/>
+          </a:ln>
+        </p:spPr>
+        <p:style>
+          <a:lnRef idx="1">
+            <a:schemeClr val="accent1"/>
+          </a:lnRef>
+          <a:fillRef idx="3">
+            <a:schemeClr val="accent1"/>
+          </a:fillRef>
+          <a:effectRef idx="2">
+            <a:schemeClr val="accent1"/>
+          </a:effectRef>
+          <a:fontRef idx="minor">
+            <a:schemeClr val="lt1"/>
+          </a:fontRef>
+        </p:style>
+        <p:txBody>
+          <a:bodyPr rtlCol="0" anchor="ctr"/>
+          <a:lstStyle/>
+          <a:p>
+            <a:pPr algn="ctr"/>
+          </a:p>
+        </p:txBody>
+      </p:sp>
+      <p:sp>
+        <p:nvSpPr>
+          <p:cNvPr id="5" name="Rounded Rectangle 4"/>
+          <p:cNvSpPr/>
+          <p:nvPr/>
+        </p:nvSpPr>
+        <p:spPr>
+          <a:xfrm>
+            <a:off x="731520" y="1645920"/>
+            <a:ext cx="5257800" cy="4251960"/>
+          </a:xfrm>
+          <a:prstGeom prst="roundRect">
+            <a:avLst/>
+          </a:prstGeom>
+          <a:solidFill>
+            <a:srgbClr val="143058"/>
+          </a:solidFill>
+          <a:ln>
+            <a:solidFill>
+              <a:srgbClr val="00B4B4"/>
+            </a:solidFill>
+          </a:ln>
+        </p:spPr>
+        <p:style>
+          <a:lnRef idx="1">
+            <a:schemeClr val="accent1"/>
+          </a:lnRef>
+          <a:fillRef idx="3">
+            <a:schemeClr val="accent1"/>
+          </a:fillRef>
+          <a:effectRef idx="2">
+            <a:schemeClr val="accent1"/>
+          </a:effectRef>
+          <a:fontRef idx="minor">
+            <a:schemeClr val="lt1"/>
+          </a:fontRef>
+        </p:style>
+        <p:txBody>
+          <a:bodyPr rtlCol="0" anchor="ctr"/>
+          <a:lstStyle/>
+          <a:p>
+            <a:pPr algn="ctr"/>
+          </a:p>
+        </p:txBody>
+      </p:sp>
+      <p:sp>
+        <p:nvSpPr>
+          <p:cNvPr id="6" name="TextBox 5"/>
+          <p:cNvSpPr txBox="1"/>
+          <p:nvPr/>
+        </p:nvSpPr>
+        <p:spPr>
+          <a:xfrm>
+            <a:off x="960120" y="1920240"/>
+            <a:ext cx="4800600" cy="365760"/>
+          </a:xfrm>
+          <a:prstGeom prst="rect">
+            <a:avLst/>
+          </a:prstGeom>
+          <a:noFill/>
+        </p:spPr>
+        <p:txBody>
+          <a:bodyPr wrap="square" anchor="t">
+            <a:spAutoFit/>
+          </a:bodyPr>
+          <a:lstStyle/>
+          <a:p>
+            <a:pPr algn="ctr">
+              <a:defRPr sz="2000" b="1">
+                <a:solidFill>
+                  <a:srgbClr val="00B4B4"/>
+                </a:solidFill>
+                <a:latin typeface="Aptos"/>
+              </a:defRPr>
+            </a:pPr>
+            <a:r>
+              <a:t>WHY XGBOOST</a:t>
+            </a:r>
+          </a:p>
+        </p:txBody>
+      </p:sp>
+      <p:sp>
+        <p:nvSpPr>
+          <p:cNvPr id="7" name="TextBox 6"/>
+          <p:cNvSpPr txBox="1"/>
+          <p:nvPr/>
+        </p:nvSpPr>
+        <p:spPr>
+          <a:xfrm>
+            <a:off x="1051560" y="2633472"/>
+            <a:ext cx="4617720" cy="3017520"/>
+          </a:xfrm>
+          <a:prstGeom prst="rect">
+            <a:avLst/>
+          </a:prstGeom>
+          <a:noFill/>
+        </p:spPr>
+        <p:txBody>
+          <a:bodyPr wrap="square" anchor="t">
+            <a:spAutoFit/>
+          </a:bodyPr>
+          <a:lstStyle/>
+          <a:p>
+            <a:pPr algn="ctr">
+              <a:defRPr sz="1500" b="0">
+                <a:solidFill>
+                  <a:srgbClr val="F0F4F8"/>
+                </a:solidFill>
+                <a:latin typeface="Aptos"/>
+              </a:defRPr>
+            </a:pPr>
+            <a:r>
+              <a:t>Best calibration + net value</a:t>
+            </a:r>
+            <a:br/>
+            <a:br/>
+            <a:r>
+              <a:t>Smallest gender FPR gap</a:t>
+            </a:r>
+            <a:br/>
+            <a:br/>
+            <a:r>
+              <a:t>SHAP-explainable</a:t>
+            </a:r>
+            <a:br/>
+            <a:br/>
+            <a:r>
+              <a:t>35× faster than the TFM</a:t>
+            </a:r>
+          </a:p>
+        </p:txBody>
+      </p:sp>
+      <p:sp>
+        <p:nvSpPr>
+          <p:cNvPr id="8" name="Rounded Rectangle 7"/>
+          <p:cNvSpPr/>
+          <p:nvPr/>
+        </p:nvSpPr>
+        <p:spPr>
+          <a:xfrm>
+            <a:off x="6217920" y="1645920"/>
+            <a:ext cx="5257800" cy="4251960"/>
+          </a:xfrm>
+          <a:prstGeom prst="roundRect">
+            <a:avLst/>
+          </a:prstGeom>
+          <a:solidFill>
+            <a:srgbClr val="143058"/>
+          </a:solidFill>
+          <a:ln>
+            <a:solidFill>
+              <a:srgbClr val="7B2CBF"/>
+            </a:solidFill>
+          </a:ln>
+        </p:spPr>
+        <p:style>
+          <a:lnRef idx="1">
+            <a:schemeClr val="accent1"/>
+          </a:lnRef>
+          <a:fillRef idx="3">
+            <a:schemeClr val="accent1"/>
+          </a:fillRef>
+          <a:effectRef idx="2">
+            <a:schemeClr val="accent1"/>
+          </a:effectRef>
+          <a:fontRef idx="minor">
+            <a:schemeClr val="lt1"/>
+          </a:fontRef>
+        </p:style>
+        <p:txBody>
+          <a:bodyPr rtlCol="0" anchor="ctr"/>
+          <a:lstStyle/>
+          <a:p>
+            <a:pPr algn="ctr"/>
+          </a:p>
+        </p:txBody>
+      </p:sp>
+      <p:sp>
+        <p:nvSpPr>
+          <p:cNvPr id="9" name="TextBox 8"/>
+          <p:cNvSpPr txBox="1"/>
+          <p:nvPr/>
+        </p:nvSpPr>
+        <p:spPr>
+          <a:xfrm>
+            <a:off x="6446520" y="1920240"/>
+            <a:ext cx="4800600" cy="365760"/>
+          </a:xfrm>
+          <a:prstGeom prst="rect">
+            <a:avLst/>
+          </a:prstGeom>
+          <a:noFill/>
+        </p:spPr>
+        <p:txBody>
+          <a:bodyPr wrap="square" anchor="t">
+            <a:spAutoFit/>
+          </a:bodyPr>
+          <a:lstStyle/>
+          <a:p>
+            <a:pPr algn="ctr">
+              <a:defRPr sz="2000" b="1">
+                <a:solidFill>
+                  <a:srgbClr val="7B2CBF"/>
+                </a:solidFill>
+                <a:latin typeface="Aptos"/>
+              </a:defRPr>
+            </a:pPr>
+            <a:r>
+              <a:t>CONDITIONS</a:t>
+            </a:r>
+          </a:p>
+        </p:txBody>
+      </p:sp>
+      <p:sp>
+        <p:nvSpPr>
+          <p:cNvPr id="10" name="TextBox 9"/>
+          <p:cNvSpPr txBox="1"/>
+          <p:nvPr/>
+        </p:nvSpPr>
+        <p:spPr>
+          <a:xfrm>
+            <a:off x="6537959" y="2633472"/>
+            <a:ext cx="4617720" cy="3017520"/>
+          </a:xfrm>
+          <a:prstGeom prst="rect">
+            <a:avLst/>
+          </a:prstGeom>
+          <a:noFill/>
+        </p:spPr>
+        <p:txBody>
+          <a:bodyPr wrap="square" anchor="t">
+            <a:spAutoFit/>
+          </a:bodyPr>
+          <a:lstStyle/>
+          <a:p>
+            <a:pPr algn="ctr">
+              <a:defRPr sz="1500" b="0">
+                <a:solidFill>
+                  <a:srgbClr val="F0F4F8"/>
+                </a:solidFill>
+                <a:latin typeface="Aptos"/>
+              </a:defRPr>
+            </a:pPr>
+            <a:r>
+              <a:t>Benefit-only allocation</a:t>
+            </a:r>
+            <a:br/>
+            <a:br/>
+            <a:r>
+              <a:t>Logistic as transparent challenger</a:t>
+            </a:r>
+            <a:br/>
+            <a:br/>
+            <a:r>
+              <a:t>Prospective shadow validation</a:t>
+            </a:r>
+            <a:br/>
+            <a:br/>
+            <a:r>
+              <a:t>Appeal route, logs, quarterly audits, stop rules</a:t>
+            </a:r>
+          </a:p>
+        </p:txBody>
+      </p:sp>
+      <p:sp>
+        <p:nvSpPr>
+          <p:cNvPr id="11" name="TextBox 10"/>
+          <p:cNvSpPr txBox="1"/>
+          <p:nvPr/>
+        </p:nvSpPr>
+        <p:spPr>
+          <a:xfrm>
+            <a:off x="594360" y="6510528"/>
+            <a:ext cx="3657600" cy="164592"/>
+          </a:xfrm>
+          <a:prstGeom prst="rect">
+            <a:avLst/>
+          </a:prstGeom>
+          <a:noFill/>
+        </p:spPr>
+        <p:txBody>
+          <a:bodyPr wrap="square" anchor="t">
+            <a:spAutoFit/>
+          </a:bodyPr>
+          <a:lstStyle/>
+          <a:p>
+            <a:pPr algn="l">
+              <a:defRPr sz="800" b="0">
+                <a:solidFill>
+                  <a:srgbClr val="828FA0"/>
+                </a:solidFill>
+                <a:latin typeface="Aptos"/>
+              </a:defRPr>
+            </a:pPr>
+            <a:r>
+              <a:t>HEC Paris · ISAF · 2026</a:t>
+            </a:r>
+          </a:p>
+        </p:txBody>
+      </p:sp>
+      <p:sp>
+        <p:nvSpPr>
+          <p:cNvPr id="12" name="TextBox 11"/>
+          <p:cNvSpPr txBox="1"/>
+          <p:nvPr/>
+        </p:nvSpPr>
+        <p:spPr>
+          <a:xfrm>
+            <a:off x="11109960" y="6492240"/>
+            <a:ext cx="411480" cy="164592"/>
+          </a:xfrm>
+          <a:prstGeom prst="rect">
+            <a:avLst/>
+          </a:prstGeom>
+          <a:noFill/>
+        </p:spPr>
+        <p:txBody>
+          <a:bodyPr wrap="square" anchor="t">
+            <a:spAutoFit/>
+          </a:bodyPr>
+          <a:lstStyle/>
+          <a:p>
+            <a:pPr algn="r">
+              <a:defRPr sz="800" b="0">
+                <a:solidFill>
+                  <a:srgbClr val="828FA0"/>
+                </a:solidFill>
+                <a:latin typeface="Aptos"/>
+              </a:defRPr>
+            </a:pPr>
+            <a:r>
+              <a:t>15</a:t>
+            </a:r>
+          </a:p>
+        </p:txBody>
+      </p:sp>
+    </p:spTree>
+  </p:cSld>
+  <p:clrMapOvr>
+    <a:masterClrMapping/>
+  </p:clrMapOvr>
+</p:sld>
+</file>
+
+<file path=ppt/slides/slide16.xml><?xml version="1.0" encoding="utf-8"?>
+<p:sld xmlns:a="http://schemas.openxmlformats.org/drawingml/2006/main" xmlns:p="http://schemas.openxmlformats.org/presentationml/2006/main" xmlns:r="http://schemas.openxmlformats.org/officeDocument/2006/relationships">
+  <p:cSld>
+    <p:bg>
+      <p:bgPr>
+        <a:solidFill>
+          <a:srgbClr val="0A1F44"/>
+        </a:solidFill>
+        <a:effectLst/>
+      </p:bgPr>
+    </p:bg>
+    <p:spTree>
+      <p:nvGrpSpPr>
+        <p:cNvPr id="1" name=""/>
+        <p:cNvGrpSpPr/>
+        <p:nvPr/>
+      </p:nvGrpSpPr>
+      <p:grpSpPr/>
+      <p:sp>
+        <p:nvSpPr>
+          <p:cNvPr id="2" name="TextBox 1"/>
+          <p:cNvSpPr txBox="1"/>
+          <p:nvPr/>
+        </p:nvSpPr>
+        <p:spPr>
+          <a:xfrm>
+            <a:off x="594360" y="256032"/>
+            <a:ext cx="10972800" cy="274320"/>
+          </a:xfrm>
+          <a:prstGeom prst="rect">
+            <a:avLst/>
+          </a:prstGeom>
+          <a:noFill/>
+        </p:spPr>
+        <p:txBody>
+          <a:bodyPr wrap="square" anchor="t">
+            <a:spAutoFit/>
+          </a:bodyPr>
+          <a:lstStyle/>
+          <a:p>
+            <a:pPr algn="l">
+              <a:defRPr sz="1000" b="1">
+                <a:solidFill>
+                  <a:srgbClr val="FB8500"/>
+                </a:solidFill>
+                <a:latin typeface="Aptos"/>
+              </a:defRPr>
+            </a:pPr>
+            <a:r>
+              <a:t>15 · CLIENT EXPERIENCE</a:t>
             </a:r>
           </a:p>
         </p:txBody>
@@ -6417,7 +6691,7 @@
               </a:defRPr>
             </a:pPr>
             <a:r>
-              <a:t>15</a:t>
+              <a:t>16</a:t>
             </a:r>
           </a:p>
         </p:txBody>

</xml_diff>

<commit_message>
Re-run pipeline on GPU at 16 estimators; leakage audit; refresh narrative
- Confirmed and kept Ayush's Gang_Affiliated->TabICL gender-leak fix; added
  scripts/leakage_audit.py (+pytest) that scans every feature's missingness vs
  race/gender, checks for post-scoring features, and verifies a disjoint split.
- Bumped TabICL to 16 ensemble members on GPU (RTX 4060); stability now 8 refits
  for all three. TabICL/XGBoost are a statistical tie (AUC 0.7328 vs 0.7326).
- Regenerated all artifacts/figures and refreshed report, slides (16), notebook,
  notes, README, JOURNEY with final numbers and the leak-discovery story.
- 7 tests pass.

Co-Authored-By: Claude Opus 4.8 <noreply@anthropic.com>
</commit_message>
<xml_diff>
--- a/reports/ISAF_Recidivism_Presentation.pptx
+++ b/reports/ISAF_Recidivism_Presentation.pptx
@@ -3570,7 +3570,7 @@
           </a:solidFill>
           <a:ln>
             <a:solidFill>
-              <a:srgbClr val="D64343"/>
+              <a:srgbClr val="00B4B4"/>
             </a:solidFill>
           </a:ln>
         </p:spPr>
@@ -3621,13 +3621,13 @@
             <a:pPr algn="ctr">
               <a:defRPr sz="2400" b="1">
                 <a:solidFill>
-                  <a:srgbClr val="D64343"/>
-                </a:solidFill>
-                <a:latin typeface="Aptos"/>
-              </a:defRPr>
-            </a:pPr>
-            <a:r>
-              <a:t>0.045</a:t>
+                  <a:srgbClr val="00B4B4"/>
+                </a:solidFill>
+                <a:latin typeface="Aptos"/>
+              </a:defRPr>
+            </a:pPr>
+            <a:r>
+              <a:t>~0.035</a:t>
             </a:r>
           </a:p>
         </p:txBody>
@@ -3663,7 +3663,7 @@
               </a:defRPr>
             </a:pPr>
             <a:r>
-              <a:t>SCORE DRIFT · TABICL</a:t>
+              <a:t>SCORE DRIFT (ALL)</a:t>
             </a:r>
           </a:p>
         </p:txBody>
@@ -3744,7 +3744,7 @@
               </a:defRPr>
             </a:pPr>
             <a:r>
-              <a:t>73–77%</a:t>
+              <a:t>76–77%</a:t>
             </a:r>
           </a:p>
         </p:txBody>
@@ -3816,7 +3816,7 @@
               </a:defRPr>
             </a:pPr>
             <a:r>
-              <a:t>~1 person in 4 changes priority status across refits — scores need governance. TabICLv2 is least stable (4 refits vs 8, a stated cost trade-off).</a:t>
+              <a:t>All three comparably stable (8 refits each). But ~1 person in 4 changes priority status across refits — scores need governance and monitoring.</a:t>
             </a:r>
           </a:p>
         </p:txBody>
@@ -4251,7 +4251,7 @@
               </a:defRPr>
             </a:pPr>
             <a:r>
-              <a:t>0.072</a:t>
+              <a:t>0.041</a:t>
             </a:r>
           </a:p>
         </p:txBody>
@@ -7613,8 +7613,8 @@
         </p:nvSpPr>
         <p:spPr>
           <a:xfrm>
-            <a:off x="731520" y="3401568"/>
-            <a:ext cx="10698480" cy="2194560"/>
+            <a:off x="731520" y="3246120"/>
+            <a:ext cx="10698480" cy="2468880"/>
           </a:xfrm>
           <a:prstGeom prst="rect">
             <a:avLst/>
@@ -7631,7 +7631,7 @@
               <a:spcAft>
                 <a:spcPts val="1200"/>
               </a:spcAft>
-              <a:defRPr sz="2000">
+              <a:defRPr sz="1800">
                 <a:solidFill>
                   <a:srgbClr val="FFFFFF"/>
                 </a:solidFill>
@@ -7647,7 +7647,7 @@
               <a:spcAft>
                 <a:spcPts val="1200"/>
               </a:spcAft>
-              <a:defRPr sz="2000">
+              <a:defRPr sz="1800">
                 <a:solidFill>
                   <a:srgbClr val="FFFFFF"/>
                 </a:solidFill>
@@ -7663,7 +7663,23 @@
               <a:spcAft>
                 <a:spcPts val="1200"/>
               </a:spcAft>
-              <a:defRPr sz="2000">
+              <a:defRPr sz="1800">
+                <a:solidFill>
+                  <a:srgbClr val="FFFFFF"/>
+                </a:solidFill>
+                <a:latin typeface="Aptos"/>
+              </a:defRPr>
+            </a:pPr>
+            <a:r>
+              <a:t>•  Found + fixed a subtle leak: Gang_Affiliated is missing for exactly the women — the foundation model read that missingness as gender (now mode-filled, regression-tested, audit script)</a:t>
+            </a:r>
+          </a:p>
+          <a:p>
+            <a:pPr>
+              <a:spcAft>
+                <a:spcPts val="1200"/>
+              </a:spcAft>
+              <a:defRPr sz="1800">
                 <a:solidFill>
                   <a:srgbClr val="FFFFFF"/>
                 </a:solidFill>
@@ -8853,7 +8869,7 @@
               </a:defRPr>
             </a:pPr>
             <a:r>
-              <a:t>+$2.4M</a:t>
+              <a:t>+$2.5M</a:t>
             </a:r>
           </a:p>
         </p:txBody>
@@ -9243,7 +9259,7 @@
               </a:defRPr>
             </a:pPr>
             <a:r>
-              <a:t>0.7338</a:t>
+              <a:t>0.7328</a:t>
             </a:r>
           </a:p>
         </p:txBody>
@@ -9360,7 +9376,7 @@
               </a:defRPr>
             </a:pPr>
             <a:r>
-              <a:t>0.2038</a:t>
+              <a:t>0.2044</a:t>
             </a:r>
           </a:p>
         </p:txBody>
@@ -10233,7 +10249,7 @@
               </a:defRPr>
             </a:pPr>
             <a:r>
-              <a:t>$5.12M</a:t>
+              <a:t>$5.26M</a:t>
             </a:r>
           </a:p>
         </p:txBody>
@@ -10350,7 +10366,7 @@
               </a:defRPr>
             </a:pPr>
             <a:r>
-              <a:t>$2.75M</a:t>
+              <a:t>$2.79M</a:t>
             </a:r>
           </a:p>
         </p:txBody>

</xml_diff>

<commit_message>
Regenerate audited results with 16-member GPU ensemble
</commit_message>
<xml_diff>
--- a/reports/ISAF_Recidivism_Presentation.pptx
+++ b/reports/ISAF_Recidivism_Presentation.pptx
@@ -3178,11 +3178,11 @@
               </a:defRPr>
             </a:pPr>
             <a:r>
-              <a:t>Better than the tool</a:t>
+              <a:t>Forecasting risk,</a:t>
             </a:r>
             <a:br/>
             <a:r>
-              <a:t>agencies already use</a:t>
+              <a:t>examining trade-offs</a:t>
             </a:r>
           </a:p>
         </p:txBody>
@@ -3570,7 +3570,7 @@
           </a:solidFill>
           <a:ln>
             <a:solidFill>
-              <a:srgbClr val="00B4B4"/>
+              <a:srgbClr val="D64343"/>
             </a:solidFill>
           </a:ln>
         </p:spPr>
@@ -3621,13 +3621,13 @@
             <a:pPr algn="ctr">
               <a:defRPr sz="2400" b="1">
                 <a:solidFill>
-                  <a:srgbClr val="00B4B4"/>
-                </a:solidFill>
-                <a:latin typeface="Aptos"/>
-              </a:defRPr>
-            </a:pPr>
-            <a:r>
-              <a:t>~0.035</a:t>
+                  <a:srgbClr val="D64343"/>
+                </a:solidFill>
+                <a:latin typeface="Aptos"/>
+              </a:defRPr>
+            </a:pPr>
+            <a:r>
+              <a:t>0.036</a:t>
             </a:r>
           </a:p>
         </p:txBody>
@@ -3663,7 +3663,7 @@
               </a:defRPr>
             </a:pPr>
             <a:r>
-              <a:t>SCORE DRIFT (ALL)</a:t>
+              <a:t>SCORE DRIFT · TABICL</a:t>
             </a:r>
           </a:p>
         </p:txBody>
@@ -3744,7 +3744,7 @@
               </a:defRPr>
             </a:pPr>
             <a:r>
-              <a:t>76–77%</a:t>
+              <a:t>77.0%</a:t>
             </a:r>
           </a:p>
         </p:txBody>
@@ -3780,7 +3780,7 @@
               </a:defRPr>
             </a:pPr>
             <a:r>
-              <a:t>TOP-20% OVERLAP</a:t>
+              <a:t>TABICL JACCARD</a:t>
             </a:r>
           </a:p>
         </p:txBody>
@@ -3816,7 +3816,7 @@
               </a:defRPr>
             </a:pPr>
             <a:r>
-              <a:t>All three comparably stable (8 refits each). But ~1 person in 4 changes priority status across refits — scores need governance and monitoring.</a:t>
+              <a:t>Jaccard is intersection / union, not the share of people switching. Refit sensitivity is not temporal validation.</a:t>
             </a:r>
           </a:p>
         </p:txBody>
@@ -3986,7 +3986,7 @@
               </a:defRPr>
             </a:pPr>
             <a:r>
-              <a:t>Fairness, audited where we actually deploy</a:t>
+              <a:t>Fairness at the proposed allocation rule</a:t>
             </a:r>
           </a:p>
         </p:txBody>
@@ -4036,7 +4036,7 @@
       </p:sp>
       <p:pic>
         <p:nvPicPr>
-          <p:cNvPr id="5" name="Picture 4" descr="fairness_operating_point.png"/>
+          <p:cNvPr id="5" name="Picture 4" descr="fairness_support_access.png"/>
           <p:cNvPicPr>
             <a:picLocks noChangeAspect="1"/>
           </p:cNvPicPr>
@@ -4134,7 +4134,7 @@
               </a:defRPr>
             </a:pPr>
             <a:r>
-              <a:t>0.036</a:t>
+              <a:t>0.039</a:t>
             </a:r>
           </a:p>
         </p:txBody>
@@ -4368,7 +4368,7 @@
               </a:defRPr>
             </a:pPr>
             <a:r>
-              <a:t>0.020</a:t>
+              <a:t>0.023</a:t>
             </a:r>
           </a:p>
         </p:txBody>
@@ -4440,7 +4440,7 @@
               </a:defRPr>
             </a:pPr>
             <a:r>
-              <a:t>At the top-20% deployment point, gaps are 2–4× smaller than at 0.5 — audit the point you ship.</a:t>
+              <a:t>Different operating points produce different allocations and errors. Audit the proposed policy.</a:t>
             </a:r>
           </a:p>
         </p:txBody>
@@ -4610,7 +4610,7 @@
               </a:defRPr>
             </a:pPr>
             <a:r>
-              <a:t>Our data shows both sides of the impossibility theorem</a:t>
+              <a:t>Fairness: probability scores and allocation rules</a:t>
             </a:r>
           </a:p>
         </p:txBody>
@@ -4734,7 +4734,7 @@
               </a:defRPr>
             </a:pPr>
             <a:r>
-              <a:t>RACE — FIXABLE</a:t>
+              <a:t>SCORE CALIBRATION</a:t>
             </a:r>
           </a:p>
         </p:txBody>
@@ -4770,21 +4770,17 @@
               </a:defRPr>
             </a:pPr>
             <a:r>
-              <a:t>Base rates near-equal</a:t>
-            </a:r>
-            <a:br/>
-            <a:r>
-              <a:t>(0.582 vs 0.564)</a:t>
+              <a:t>Do probabilities match observed rates?</a:t>
             </a:r>
             <a:br/>
             <a:br/>
             <a:r>
-              <a:t>Calibration + equal error jointly achievable</a:t>
+              <a:t>Report group calibration and uncertainty</a:t>
             </a:r>
             <a:br/>
             <a:br/>
             <a:r>
-              <a:t>FPR gap is a model property → group thresholds drive it to ~0</a:t>
+              <a:t>Changing decision thresholds leaves probabilities unchanged</a:t>
             </a:r>
           </a:p>
         </p:txBody>
@@ -4865,7 +4861,7 @@
               </a:defRPr>
             </a:pPr>
             <a:r>
-              <a:t>GENDER — BINDS</a:t>
+              <a:t>ALLOCATION ERRORS</a:t>
             </a:r>
           </a:p>
         </p:txBody>
@@ -4901,21 +4897,17 @@
               </a:defRPr>
             </a:pPr>
             <a:r>
-              <a:t>Base rates differ 13.7 pts</a:t>
-            </a:r>
-            <a:br/>
-            <a:r>
-              <a:t>(0.591 vs 0.454)</a:t>
+              <a:t>FPR, TPR and selection rates depend on policy</a:t>
             </a:r>
             <a:br/>
             <a:br/>
             <a:r>
-              <a:t>Theorem binds: cannot equalize both</a:t>
+              <a:t>Equal FPR alone is not equalized odds</a:t>
             </a:r>
             <a:br/>
             <a:br/>
             <a:r>
-              <a:t>Equalizing gender FPR decalibrates women — a choice we surface, not hide</a:t>
+              <a:t>Our threshold frontier uses evaluation labels: illustrative, not validated</a:t>
             </a:r>
           </a:p>
         </p:txBody>
@@ -5150,7 +5142,7 @@
         <p:spPr>
           <a:xfrm>
             <a:off x="502920" y="1600200"/>
-            <a:ext cx="11155680" cy="4049941"/>
+            <a:ext cx="11155680" cy="4030062"/>
           </a:xfrm>
           <a:prstGeom prst="rect">
             <a:avLst/>
@@ -5422,8 +5414,8 @@
         </p:blipFill>
         <p:spPr>
           <a:xfrm>
-            <a:off x="2011680" y="1481328"/>
-            <a:ext cx="8138160" cy="6081764"/>
+            <a:off x="2881094" y="1481328"/>
+            <a:ext cx="6399331" cy="4782312"/>
           </a:xfrm>
           <a:prstGeom prst="rect">
             <a:avLst/>
@@ -5595,7 +5587,7 @@
               </a:defRPr>
             </a:pPr>
             <a:r>
-              <a:t>Deploy XGBoost; challenger logistic; TabICL for small agencies</a:t>
+              <a:t>Pilot XGBoost; retain logistic as a transparent challenger</a:t>
             </a:r>
           </a:p>
         </p:txBody>
@@ -5755,22 +5747,22 @@
               </a:defRPr>
             </a:pPr>
             <a:r>
-              <a:t>Best calibration + net value</a:t>
+              <a:t>Competitive probability loss</a:t>
             </a:r>
             <a:br/>
             <a:br/>
             <a:r>
-              <a:t>Smallest gender FPR gap</a:t>
+              <a:t>Audit subgroup errors</a:t>
             </a:r>
             <a:br/>
             <a:br/>
             <a:r>
-              <a:t>SHAP-explainable</a:t>
+              <a:t>SHAP explanations available</a:t>
             </a:r>
             <a:br/>
             <a:br/>
             <a:r>
-              <a:t>35× faster than the TFM</a:t>
+              <a:t>Low inference cost</a:t>
             </a:r>
           </a:p>
         </p:txBody>
@@ -7089,7 +7081,7 @@
               </a:defRPr>
             </a:pPr>
             <a:r>
-              <a:t>A clean test set and a strict time boundary</a:t>
+              <a:t>Original split, with explicit validation limits</a:t>
             </a:r>
           </a:p>
         </p:txBody>
@@ -7366,7 +7358,7 @@
               </a:defRPr>
             </a:pPr>
             <a:r>
-              <a:t>UNTOUCHED TEST</a:t>
+              <a:t>EVALUATION</a:t>
             </a:r>
           </a:p>
         </p:txBody>
@@ -7613,8 +7605,8 @@
         </p:nvSpPr>
         <p:spPr>
           <a:xfrm>
-            <a:off x="731520" y="3246120"/>
-            <a:ext cx="10698480" cy="2468880"/>
+            <a:off x="731520" y="3310128"/>
+            <a:ext cx="10698480" cy="2423160"/>
           </a:xfrm>
           <a:prstGeom prst="rect">
             <a:avLst/>
@@ -7639,7 +7631,7 @@
               </a:defRPr>
             </a:pPr>
             <a:r>
-              <a:t>•  Post-release violations, tests, programs and employment excluded to prevent leakage</a:t>
+              <a:t>•  Post-release variables excluded; race, gender and geography retained only for audit</a:t>
             </a:r>
           </a:p>
           <a:p>
@@ -7655,7 +7647,7 @@
               </a:defRPr>
             </a:pPr>
             <a:r>
-              <a:t>•  Race, gender and residence geography excluded from scoring; kept only in the audit layer</a:t>
+              <a:t>•  Found and fixed a representation leak: missing gang affiliation exactly marked women; mode-fill plus a regression audit now blocks it</a:t>
             </a:r>
           </a:p>
           <a:p>
@@ -7671,23 +7663,7 @@
               </a:defRPr>
             </a:pPr>
             <a:r>
-              <a:t>•  Found + fixed a subtle leak: Gang_Affiliated is missing for exactly the women — the foundation model read that missingness as gender (now mode-filled, regression-tested, audit script)</a:t>
-            </a:r>
-          </a:p>
-          <a:p>
-            <a:pPr>
-              <a:spcAft>
-                <a:spcPts val="1200"/>
-              </a:spcAft>
-              <a:defRPr sz="1800">
-                <a:solidFill>
-                  <a:srgbClr val="FFFFFF"/>
-                </a:solidFill>
-                <a:latin typeface="Aptos"/>
-              </a:defRPr>
-            </a:pPr>
-            <a:r>
-              <a:t>•  Balanced outcome (57.8%), so no resampling; official NIJ split preserves an honest evaluation</a:t>
+              <a:t>•  Evaluation data were repeatedly inspected during development; fresh validation is still needed</a:t>
             </a:r>
           </a:p>
         </p:txBody>
@@ -8022,7 +7998,7 @@
             <a:br/>
             <a:br/>
             <a:r>
-              <a:t>Regularized linear score</a:t>
+              <a:t>CV-tuned L1, C=0.2154</a:t>
             </a:r>
             <a:br/>
             <a:br/>
@@ -8276,12 +8252,12 @@
             <a:br/>
             <a:br/>
             <a:r>
-              <a:t>Pretrained in-context transformer</a:t>
+              <a:t>16-member GPU ensemble</a:t>
             </a:r>
             <a:br/>
             <a:br/>
             <a:r>
-              <a:t>No training, no native explanation</a:t>
+              <a:t>Training-only size sweep; no native attribution implemented</a:t>
             </a:r>
           </a:p>
         </p:txBody>
@@ -8487,7 +8463,7 @@
               </a:defRPr>
             </a:pPr>
             <a:r>
-              <a:t>Is any of this better than today's tool?</a:t>
+              <a:t>Comparison with the historical recorded score</a:t>
             </a:r>
           </a:p>
         </p:txBody>
@@ -8869,7 +8845,7 @@
               </a:defRPr>
             </a:pPr>
             <a:r>
-              <a:t>+$2.5M</a:t>
+              <a:t>+$2.4M</a:t>
             </a:r>
           </a:p>
         </p:txBody>
@@ -8941,7 +8917,7 @@
               </a:defRPr>
             </a:pPr>
             <a:r>
-              <a:t>The existing 1–10 actuarial score is barely better than a coin flip at ranking. Any model nearly doubles net value.</a:t>
+              <a:t>This historical comparison does not establish superiority to current agency products. Dollar gains are scenarios.</a:t>
             </a:r>
           </a:p>
         </p:txBody>
@@ -9111,7 +9087,7 @@
               </a:defRPr>
             </a:pPr>
             <a:r>
-              <a:t>Among the three: a near-tie, XGBoost calibrates best</a:t>
+              <a:t>Compare ranking, probability loss and calibration</a:t>
             </a:r>
           </a:p>
         </p:txBody>
@@ -9295,7 +9271,7 @@
               </a:defRPr>
             </a:pPr>
             <a:r>
-              <a:t>BEST AUC · TABICL</a:t>
+              <a:t>AUC · TABICL</a:t>
             </a:r>
           </a:p>
         </p:txBody>
@@ -9412,7 +9388,7 @@
               </a:defRPr>
             </a:pPr>
             <a:r>
-              <a:t>BEST BRIER · TABICL</a:t>
+              <a:t>BRIER · TABICL</a:t>
             </a:r>
           </a:p>
         </p:txBody>
@@ -9493,7 +9469,7 @@
               </a:defRPr>
             </a:pPr>
             <a:r>
-              <a:t>0.0109</a:t>
+              <a:t>0.0112</a:t>
             </a:r>
           </a:p>
         </p:txBody>
@@ -9529,7 +9505,7 @@
               </a:defRPr>
             </a:pPr>
             <a:r>
-              <a:t>BEST ECE · XGBOOST</a:t>
+              <a:t>ECE · XGBOOST</a:t>
             </a:r>
           </a:p>
         </p:txBody>
@@ -9565,7 +9541,7 @@
               </a:defRPr>
             </a:pPr>
             <a:r>
-              <a:t>Bootstrap 95% intervals overlap — the ranking among the three is not decisive.</a:t>
+              <a:t>Paired bootstrap compares differences directly; see paired_comparisons.csv. Results remain exploratory.</a:t>
             </a:r>
           </a:p>
         </p:txBody>
@@ -9838,7 +9814,7 @@
               </a:defRPr>
             </a:pPr>
             <a:r>
-              <a:t>TabICLv2 leads on small data (small county); XGBoost catches up as data grows (large state). No crossover — but the gap closes to +0.004 at full data.</a:t>
+              <a:t>Subsamples of one Georgia cohort test sample-size sensitivity; they do not validate transfer to other agencies.</a:t>
             </a:r>
           </a:p>
         </p:txBody>
@@ -10249,7 +10225,7 @@
               </a:defRPr>
             </a:pPr>
             <a:r>
-              <a:t>$5.26M</a:t>
+              <a:t>$5.17M</a:t>
             </a:r>
           </a:p>
         </p:txBody>
@@ -10366,7 +10342,7 @@
               </a:defRPr>
             </a:pPr>
             <a:r>
-              <a:t>$2.79M</a:t>
+              <a:t>$2.73M</a:t>
             </a:r>
           </a:p>
         </p:txBody>
@@ -10760,7 +10736,7 @@
               </a:defRPr>
             </a:pPr>
             <a:r>
-              <a:t>Every prediction, and the performance, explained</a:t>
+              <a:t>Prediction explanations and their limits</a:t>
             </a:r>
           </a:p>
         </p:txBody>
@@ -10825,7 +10801,7 @@
         <p:spPr>
           <a:xfrm>
             <a:off x="365760" y="1554480"/>
-            <a:ext cx="7589520" cy="2871452"/>
+            <a:ext cx="7589520" cy="2869645"/>
           </a:xfrm>
           <a:prstGeom prst="rect">
             <a:avLst/>
@@ -10954,7 +10930,7 @@
             <a:br/>
             <a:br/>
             <a:r>
-              <a:t>Global surrogate R²=0.61</a:t>
+              <a:t>Global surrogate: imperfect fidelity</a:t>
             </a:r>
             <a:br/>
             <a:br/>

</xml_diff>

<commit_message>
Regenerate course-aligned fairness outputs; update PLAN status audit
</commit_message>
<xml_diff>
--- a/reports/ISAF_Recidivism_Presentation.pptx
+++ b/reports/ISAF_Recidivism_Presentation.pptx
@@ -4051,7 +4051,7 @@
         <p:spPr>
           <a:xfrm>
             <a:off x="365760" y="1554480"/>
-            <a:ext cx="7772400" cy="2809534"/>
+            <a:ext cx="7772400" cy="4216673"/>
           </a:xfrm>
           <a:prstGeom prst="rect">
             <a:avLst/>
@@ -5414,8 +5414,8 @@
         </p:blipFill>
         <p:spPr>
           <a:xfrm>
-            <a:off x="2881094" y="1481328"/>
-            <a:ext cx="6399331" cy="4782312"/>
+            <a:off x="2883596" y="1481328"/>
+            <a:ext cx="6394327" cy="4782312"/>
           </a:xfrm>
           <a:prstGeom prst="rect">
             <a:avLst/>

</xml_diff>

<commit_message>
Write up course-aligned fairness results across deck, notebook, report and notes
</commit_message>
<xml_diff>
--- a/reports/ISAF_Recidivism_Presentation.pptx
+++ b/reports/ISAF_Recidivism_Presentation.pptx
@@ -21,6 +21,7 @@
     <p:sldId id="269" r:id="rId20"/>
     <p:sldId id="270" r:id="rId21"/>
     <p:sldId id="271" r:id="rId22"/>
+    <p:sldId id="272" r:id="rId23"/>
   </p:sldIdLst>
   <p:sldSz cx="12191695" cy="6858000" type="screen4x3"/>
   <p:notesSz cx="6858000" cy="9144000"/>
@@ -4077,7 +4078,7 @@
           </a:solidFill>
           <a:ln>
             <a:solidFill>
-              <a:srgbClr val="00B4B4"/>
+              <a:srgbClr val="D64343"/>
             </a:solidFill>
           </a:ln>
         </p:spPr>
@@ -4128,13 +4129,13 @@
             <a:pPr algn="ctr">
               <a:defRPr sz="2400" b="1">
                 <a:solidFill>
-                  <a:srgbClr val="00B4B4"/>
-                </a:solidFill>
-                <a:latin typeface="Aptos"/>
-              </a:defRPr>
-            </a:pPr>
-            <a:r>
-              <a:t>0.039</a:t>
+                  <a:srgbClr val="D64343"/>
+                </a:solidFill>
+                <a:latin typeface="Aptos"/>
+              </a:defRPr>
+            </a:pPr>
+            <a:r>
+              <a:t>-0.10 to -0.12</a:t>
             </a:r>
           </a:p>
         </p:txBody>
@@ -4170,14 +4171,50 @@
               </a:defRPr>
             </a:pPr>
             <a:r>
-              <a:t>GENDER FPR · XGB</a:t>
-            </a:r>
-          </a:p>
-        </p:txBody>
-      </p:sp>
-      <p:sp>
-        <p:nvSpPr>
-          <p:cNvPr id="9" name="Rounded Rectangle 8"/>
+              <a:t>GENDER FNR GAP (M − F)</a:t>
+            </a:r>
+          </a:p>
+        </p:txBody>
+      </p:sp>
+      <p:sp>
+        <p:nvSpPr>
+          <p:cNvPr id="9" name="TextBox 8"/>
+          <p:cNvSpPr txBox="1"/>
+          <p:nvPr/>
+        </p:nvSpPr>
+        <p:spPr>
+          <a:xfrm>
+            <a:off x="8659367" y="2706624"/>
+            <a:ext cx="2194560" cy="164592"/>
+          </a:xfrm>
+          <a:prstGeom prst="rect">
+            <a:avLst/>
+          </a:prstGeom>
+          <a:noFill/>
+        </p:spPr>
+        <p:txBody>
+          <a:bodyPr wrap="square" anchor="t">
+            <a:spAutoFit/>
+          </a:bodyPr>
+          <a:lstStyle/>
+          <a:p>
+            <a:pPr algn="ctr">
+              <a:defRPr sz="800" b="0">
+                <a:solidFill>
+                  <a:srgbClr val="F0F4F8"/>
+                </a:solidFill>
+                <a:latin typeface="Aptos"/>
+              </a:defRPr>
+            </a:pPr>
+            <a:r>
+              <a:t>women miss support more · all significant</a:t>
+            </a:r>
+          </a:p>
+        </p:txBody>
+      </p:sp>
+      <p:sp>
+        <p:nvSpPr>
+          <p:cNvPr id="10" name="Rounded Rectangle 9"/>
           <p:cNvSpPr/>
           <p:nvPr/>
         </p:nvSpPr>
@@ -4194,7 +4231,7 @@
           </a:solidFill>
           <a:ln>
             <a:solidFill>
-              <a:srgbClr val="D64343"/>
+              <a:srgbClr val="00B4B4"/>
             </a:solidFill>
           </a:ln>
         </p:spPr>
@@ -4222,7 +4259,7 @@
       </p:sp>
       <p:sp>
         <p:nvSpPr>
-          <p:cNvPr id="10" name="TextBox 9"/>
+          <p:cNvPr id="11" name="TextBox 10"/>
           <p:cNvSpPr txBox="1"/>
           <p:nvPr/>
         </p:nvSpPr>
@@ -4245,20 +4282,20 @@
             <a:pPr algn="ctr">
               <a:defRPr sz="2400" b="1">
                 <a:solidFill>
-                  <a:srgbClr val="D64343"/>
-                </a:solidFill>
-                <a:latin typeface="Aptos"/>
-              </a:defRPr>
-            </a:pPr>
-            <a:r>
-              <a:t>0.041</a:t>
-            </a:r>
-          </a:p>
-        </p:txBody>
-      </p:sp>
-      <p:sp>
-        <p:nvSpPr>
-          <p:cNvPr id="11" name="TextBox 10"/>
+                  <a:srgbClr val="00B4B4"/>
+                </a:solidFill>
+                <a:latin typeface="Aptos"/>
+              </a:defRPr>
+            </a:pPr>
+            <a:r>
+              <a:t>3 / 3 models</a:t>
+            </a:r>
+          </a:p>
+        </p:txBody>
+      </p:sp>
+      <p:sp>
+        <p:nvSpPr>
+          <p:cNvPr id="12" name="TextBox 11"/>
           <p:cNvSpPr txBox="1"/>
           <p:nvPr/>
         </p:nvSpPr>
@@ -4287,14 +4324,50 @@
               </a:defRPr>
             </a:pPr>
             <a:r>
-              <a:t>GENDER FPR · TABICL</a:t>
-            </a:r>
-          </a:p>
-        </p:txBody>
-      </p:sp>
-      <p:sp>
-        <p:nvSpPr>
-          <p:cNvPr id="12" name="Rounded Rectangle 11"/>
+              <a:t>RACE: EQUIVALENT ±5 PTS</a:t>
+            </a:r>
+          </a:p>
+        </p:txBody>
+      </p:sp>
+      <p:sp>
+        <p:nvSpPr>
+          <p:cNvPr id="13" name="TextBox 12"/>
+          <p:cNvSpPr txBox="1"/>
+          <p:nvPr/>
+        </p:nvSpPr>
+        <p:spPr>
+          <a:xfrm>
+            <a:off x="8659367" y="4169664"/>
+            <a:ext cx="2194560" cy="164592"/>
+          </a:xfrm>
+          <a:prstGeom prst="rect">
+            <a:avLst/>
+          </a:prstGeom>
+          <a:noFill/>
+        </p:spPr>
+        <p:txBody>
+          <a:bodyPr wrap="square" anchor="t">
+            <a:spAutoFit/>
+          </a:bodyPr>
+          <a:lstStyle/>
+          <a:p>
+            <a:pPr algn="ctr">
+              <a:defRPr sz="800" b="0">
+                <a:solidFill>
+                  <a:srgbClr val="F0F4F8"/>
+                </a:solidFill>
+                <a:latin typeface="Aptos"/>
+              </a:defRPr>
+            </a:pPr>
+            <a:r>
+              <a:t>TOST on selection, FNR, FPR</a:t>
+            </a:r>
+          </a:p>
+        </p:txBody>
+      </p:sp>
+      <p:sp>
+        <p:nvSpPr>
+          <p:cNvPr id="14" name="Rounded Rectangle 13"/>
           <p:cNvSpPr/>
           <p:nvPr/>
         </p:nvSpPr>
@@ -4339,7 +4412,7 @@
       </p:sp>
       <p:sp>
         <p:nvSpPr>
-          <p:cNvPr id="13" name="TextBox 12"/>
+          <p:cNvPr id="15" name="TextBox 14"/>
           <p:cNvSpPr txBox="1"/>
           <p:nvPr/>
         </p:nvSpPr>
@@ -4368,14 +4441,14 @@
               </a:defRPr>
             </a:pPr>
             <a:r>
-              <a:t>0.023</a:t>
-            </a:r>
-          </a:p>
-        </p:txBody>
-      </p:sp>
-      <p:sp>
-        <p:nvSpPr>
-          <p:cNvPr id="14" name="TextBox 13"/>
+              <a:t>-0.23 to -0.24</a:t>
+            </a:r>
+          </a:p>
+        </p:txBody>
+      </p:sp>
+      <p:sp>
+        <p:nvSpPr>
+          <p:cNvPr id="16" name="TextBox 15"/>
           <p:cNvSpPr txBox="1"/>
           <p:nvPr/>
         </p:nvSpPr>
@@ -4404,14 +4477,50 @@
               </a:defRPr>
             </a:pPr>
             <a:r>
-              <a:t>RACE FPR · XGB</a:t>
-            </a:r>
-          </a:p>
-        </p:txBody>
-      </p:sp>
-      <p:sp>
-        <p:nvSpPr>
-          <p:cNvPr id="15" name="TextBox 14"/>
+              <a:t>AGE FNR GAP (&lt;33 − 33+)</a:t>
+            </a:r>
+          </a:p>
+        </p:txBody>
+      </p:sp>
+      <p:sp>
+        <p:nvSpPr>
+          <p:cNvPr id="17" name="TextBox 16"/>
+          <p:cNvSpPr txBox="1"/>
+          <p:nvPr/>
+        </p:nvSpPr>
+        <p:spPr>
+          <a:xfrm>
+            <a:off x="8659367" y="5632704"/>
+            <a:ext cx="2194560" cy="164592"/>
+          </a:xfrm>
+          <a:prstGeom prst="rect">
+            <a:avLst/>
+          </a:prstGeom>
+          <a:noFill/>
+        </p:spPr>
+        <p:txBody>
+          <a:bodyPr wrap="square" anchor="t">
+            <a:spAutoFit/>
+          </a:bodyPr>
+          <a:lstStyle/>
+          <a:p>
+            <a:pPr algn="ctr">
+              <a:defRPr sz="800" b="0">
+                <a:solidFill>
+                  <a:srgbClr val="F0F4F8"/>
+                </a:solidFill>
+                <a:latin typeface="Aptos"/>
+              </a:defRPr>
+            </a:pPr>
+            <a:r>
+              <a:t>age is an input: needs a stated justification</a:t>
+            </a:r>
+          </a:p>
+        </p:txBody>
+      </p:sp>
+      <p:sp>
+        <p:nvSpPr>
+          <p:cNvPr id="18" name="TextBox 17"/>
           <p:cNvSpPr txBox="1"/>
           <p:nvPr/>
         </p:nvSpPr>
@@ -4440,14 +4549,14 @@
               </a:defRPr>
             </a:pPr>
             <a:r>
-              <a:t>Different operating points produce different allocations and errors. Audit the proposed policy.</a:t>
-            </a:r>
-          </a:p>
-        </p:txBody>
-      </p:sp>
-      <p:sp>
-        <p:nvSpPr>
-          <p:cNvPr id="16" name="TextBox 15"/>
+              <a:t>Selection = support offered, so the harm is a missed offer: FNR is primary. Not significant ≠ fair; we test equivalence.</a:t>
+            </a:r>
+          </a:p>
+        </p:txBody>
+      </p:sp>
+      <p:sp>
+        <p:nvSpPr>
+          <p:cNvPr id="19" name="TextBox 18"/>
           <p:cNvSpPr txBox="1"/>
           <p:nvPr/>
         </p:nvSpPr>
@@ -4483,7 +4592,7 @@
       </p:sp>
       <p:sp>
         <p:nvSpPr>
-          <p:cNvPr id="17" name="TextBox 16"/>
+          <p:cNvPr id="20" name="TextBox 19"/>
           <p:cNvSpPr txBox="1"/>
           <p:nvPr/>
         </p:nvSpPr>
@@ -4770,12 +4879,12 @@
               </a:defRPr>
             </a:pPr>
             <a:r>
-              <a:t>Do probabilities match observed rates?</a:t>
+              <a:t>Women are over-predicted by every model: mean score 0.52 vs observed 0.45</a:t>
             </a:r>
             <a:br/>
             <a:br/>
             <a:r>
-              <a:t>Report group calibration and uncertainty</a:t>
+              <a:t>Yet they are selected less at the top 20%</a:t>
             </a:r>
             <a:br/>
             <a:br/>
@@ -5041,7 +5150,7 @@
               </a:defRPr>
             </a:pPr>
             <a:r>
-              <a:t>12 · PROCESS</a:t>
+              <a:t>12 · FAIRNESS INTERPRETABILITY (FPDP)</a:t>
             </a:r>
           </a:p>
         </p:txBody>
@@ -5077,7 +5186,7 @@
               </a:defRPr>
             </a:pPr>
             <a:r>
-              <a:t>How we got here: what we tried, where we landed</a:t>
+              <a:t>Where does the gender gap come from?</a:t>
             </a:r>
           </a:p>
         </p:txBody>
@@ -5127,7 +5236,7 @@
       </p:sp>
       <p:pic>
         <p:nvPicPr>
-          <p:cNvPr id="5" name="Picture 4" descr="improvement_journey.png"/>
+          <p:cNvPr id="5" name="Picture 4" descr="fpdp_gender.png"/>
           <p:cNvPicPr>
             <a:picLocks noChangeAspect="1"/>
           </p:cNvPicPr>
@@ -5141,8 +5250,8 @@
         </p:blipFill>
         <p:spPr>
           <a:xfrm>
-            <a:off x="502920" y="1600200"/>
-            <a:ext cx="11155680" cy="4030062"/>
+            <a:off x="320040" y="1508760"/>
+            <a:ext cx="7680960" cy="4743933"/>
           </a:xfrm>
           <a:prstGeom prst="rect">
             <a:avLst/>
@@ -5151,7 +5260,139 @@
       </p:pic>
       <p:sp>
         <p:nvSpPr>
-          <p:cNvPr id="6" name="TextBox 5"/>
+          <p:cNvPr id="6" name="Rounded Rectangle 5"/>
+          <p:cNvSpPr/>
+          <p:nvPr/>
+        </p:nvSpPr>
+        <p:spPr>
+          <a:xfrm>
+            <a:off x="8229600" y="1508760"/>
+            <a:ext cx="3611880" cy="4572000"/>
+          </a:xfrm>
+          <a:prstGeom prst="roundRect">
+            <a:avLst/>
+          </a:prstGeom>
+          <a:solidFill>
+            <a:srgbClr val="143058"/>
+          </a:solidFill>
+          <a:ln>
+            <a:solidFill>
+              <a:srgbClr val="D64343"/>
+            </a:solidFill>
+          </a:ln>
+        </p:spPr>
+        <p:style>
+          <a:lnRef idx="1">
+            <a:schemeClr val="accent1"/>
+          </a:lnRef>
+          <a:fillRef idx="3">
+            <a:schemeClr val="accent1"/>
+          </a:fillRef>
+          <a:effectRef idx="2">
+            <a:schemeClr val="accent1"/>
+          </a:effectRef>
+          <a:fontRef idx="minor">
+            <a:schemeClr val="lt1"/>
+          </a:fontRef>
+        </p:style>
+        <p:txBody>
+          <a:bodyPr rtlCol="0" anchor="ctr"/>
+          <a:lstStyle/>
+          <a:p>
+            <a:pPr algn="ctr"/>
+          </a:p>
+        </p:txBody>
+      </p:sp>
+      <p:sp>
+        <p:nvSpPr>
+          <p:cNvPr id="7" name="TextBox 6"/>
+          <p:cNvSpPr txBox="1"/>
+          <p:nvPr/>
+        </p:nvSpPr>
+        <p:spPr>
+          <a:xfrm>
+            <a:off x="8458200" y="1783080"/>
+            <a:ext cx="3154680" cy="365760"/>
+          </a:xfrm>
+          <a:prstGeom prst="rect">
+            <a:avLst/>
+          </a:prstGeom>
+          <a:noFill/>
+        </p:spPr>
+        <p:txBody>
+          <a:bodyPr wrap="square" anchor="t">
+            <a:spAutoFit/>
+          </a:bodyPr>
+          <a:lstStyle/>
+          <a:p>
+            <a:pPr algn="ctr">
+              <a:defRPr sz="2000" b="1">
+                <a:solidFill>
+                  <a:srgbClr val="D64343"/>
+                </a:solidFill>
+                <a:latin typeface="Aptos"/>
+              </a:defRPr>
+            </a:pPr>
+            <a:r>
+              <a:t>CANDIDATE: GANG</a:t>
+            </a:r>
+          </a:p>
+        </p:txBody>
+      </p:sp>
+      <p:sp>
+        <p:nvSpPr>
+          <p:cNvPr id="8" name="TextBox 7"/>
+          <p:cNvSpPr txBox="1"/>
+          <p:nvPr/>
+        </p:nvSpPr>
+        <p:spPr>
+          <a:xfrm>
+            <a:off x="8549640" y="2496312"/>
+            <a:ext cx="2971800" cy="3337560"/>
+          </a:xfrm>
+          <a:prstGeom prst="rect">
+            <a:avLst/>
+          </a:prstGeom>
+          <a:noFill/>
+        </p:spPr>
+        <p:txBody>
+          <a:bodyPr wrap="square" anchor="t">
+            <a:spAutoFit/>
+          </a:bodyPr>
+          <a:lstStyle/>
+          <a:p>
+            <a:pPr algn="ctr">
+              <a:defRPr sz="1500" b="0">
+                <a:solidFill>
+                  <a:srgbClr val="F0F4F8"/>
+                </a:solidFill>
+                <a:latin typeface="Aptos"/>
+              </a:defRPr>
+            </a:pPr>
+            <a:r>
+              <a:t>Never recorded for women; imputed as "No"</a:t>
+            </a:r>
+            <a:br/>
+            <a:br/>
+            <a:r>
+              <a:t>Drop + re-estimate: equal-opportunity p 0.000 → 0.995 (logistic)</a:t>
+            </a:r>
+            <a:br/>
+            <a:br/>
+            <a:r>
+              <a:t>AUC cost ≈ 0.014, ~6× the XGB − logistic gap</a:t>
+            </a:r>
+            <a:br/>
+            <a:br/>
+            <a:r>
+              <a:t>Statistical parity still rejected</a:t>
+            </a:r>
+          </a:p>
+        </p:txBody>
+      </p:sp>
+      <p:sp>
+        <p:nvSpPr>
+          <p:cNvPr id="9" name="TextBox 8"/>
           <p:cNvSpPr txBox="1"/>
           <p:nvPr/>
         </p:nvSpPr>
@@ -5180,14 +5421,14 @@
               </a:defRPr>
             </a:pPr>
             <a:r>
-              <a:t>Full log in JOURNEY.md — every step measured, including the attempts we rejected.</a:t>
-            </a:r>
-          </a:p>
-        </p:txBody>
-      </p:sp>
-      <p:sp>
-        <p:nvSpPr>
-          <p:cNvPr id="7" name="TextBox 6"/>
+              <a:t>FPDP identifies candidate variables (association, not causation). Mitigation is evaluated on the same labels: illustrative.</a:t>
+            </a:r>
+          </a:p>
+        </p:txBody>
+      </p:sp>
+      <p:sp>
+        <p:nvSpPr>
+          <p:cNvPr id="10" name="TextBox 9"/>
           <p:cNvSpPr txBox="1"/>
           <p:nvPr/>
         </p:nvSpPr>
@@ -5223,7 +5464,7 @@
       </p:sp>
       <p:sp>
         <p:nvSpPr>
-          <p:cNvPr id="8" name="TextBox 7"/>
+          <p:cNvPr id="11" name="TextBox 10"/>
           <p:cNvSpPr txBox="1"/>
           <p:nvPr/>
         </p:nvSpPr>
@@ -5314,7 +5555,7 @@
               </a:defRPr>
             </a:pPr>
             <a:r>
-              <a:t>13 · TRADE-OFFS ACROSS FOUR DIMENSIONS</a:t>
+              <a:t>13 · PROCESS</a:t>
             </a:r>
           </a:p>
         </p:txBody>
@@ -5350,7 +5591,7 @@
               </a:defRPr>
             </a:pPr>
             <a:r>
-              <a:t>Which model should the client deploy?</a:t>
+              <a:t>How we got here: what we tried, where we landed</a:t>
             </a:r>
           </a:p>
         </p:txBody>
@@ -5400,7 +5641,7 @@
       </p:sp>
       <p:pic>
         <p:nvPicPr>
-          <p:cNvPr id="5" name="Picture 4" descr="tradeoff_matrix.png"/>
+          <p:cNvPr id="5" name="Picture 4" descr="improvement_journey.png"/>
           <p:cNvPicPr>
             <a:picLocks noChangeAspect="1"/>
           </p:cNvPicPr>
@@ -5414,8 +5655,8 @@
         </p:blipFill>
         <p:spPr>
           <a:xfrm>
-            <a:off x="2883596" y="1481328"/>
-            <a:ext cx="6394327" cy="4782312"/>
+            <a:off x="502920" y="1600200"/>
+            <a:ext cx="11155680" cy="4030062"/>
           </a:xfrm>
           <a:prstGeom prst="rect">
             <a:avLst/>
@@ -5425,6 +5666,42 @@
       <p:sp>
         <p:nvSpPr>
           <p:cNvPr id="6" name="TextBox 5"/>
+          <p:cNvSpPr txBox="1"/>
+          <p:nvPr/>
+        </p:nvSpPr>
+        <p:spPr>
+          <a:xfrm>
+            <a:off x="914400" y="6236208"/>
+            <a:ext cx="10058400" cy="274320"/>
+          </a:xfrm>
+          <a:prstGeom prst="rect">
+            <a:avLst/>
+          </a:prstGeom>
+          <a:noFill/>
+        </p:spPr>
+        <p:txBody>
+          <a:bodyPr wrap="square" anchor="t">
+            <a:spAutoFit/>
+          </a:bodyPr>
+          <a:lstStyle/>
+          <a:p>
+            <a:pPr algn="ctr">
+              <a:defRPr sz="1100" b="1">
+                <a:solidFill>
+                  <a:srgbClr val="FB8500"/>
+                </a:solidFill>
+                <a:latin typeface="Aptos"/>
+              </a:defRPr>
+            </a:pPr>
+            <a:r>
+              <a:t>Full log in JOURNEY.md — every step measured, including the attempts we rejected.</a:t>
+            </a:r>
+          </a:p>
+        </p:txBody>
+      </p:sp>
+      <p:sp>
+        <p:nvSpPr>
+          <p:cNvPr id="7" name="TextBox 6"/>
           <p:cNvSpPr txBox="1"/>
           <p:nvPr/>
         </p:nvSpPr>
@@ -5460,7 +5737,7 @@
       </p:sp>
       <p:sp>
         <p:nvSpPr>
-          <p:cNvPr id="7" name="TextBox 6"/>
+          <p:cNvPr id="8" name="TextBox 7"/>
           <p:cNvSpPr txBox="1"/>
           <p:nvPr/>
         </p:nvSpPr>
@@ -5551,7 +5828,7 @@
               </a:defRPr>
             </a:pPr>
             <a:r>
-              <a:t>14 · RECOMMENDATION</a:t>
+              <a:t>14 · TRADE-OFFS ACROSS FOUR DIMENSIONS</a:t>
             </a:r>
           </a:p>
         </p:txBody>
@@ -5587,7 +5864,7 @@
               </a:defRPr>
             </a:pPr>
             <a:r>
-              <a:t>Pilot XGBoost; retain logistic as a transparent challenger</a:t>
+              <a:t>Which model should the client deploy?</a:t>
             </a:r>
           </a:p>
         </p:txBody>
@@ -5635,273 +5912,33 @@
           </a:p>
         </p:txBody>
       </p:sp>
-      <p:sp>
-        <p:nvSpPr>
-          <p:cNvPr id="5" name="Rounded Rectangle 4"/>
-          <p:cNvSpPr/>
-          <p:nvPr/>
-        </p:nvSpPr>
-        <p:spPr>
-          <a:xfrm>
-            <a:off x="731520" y="1645920"/>
-            <a:ext cx="5257800" cy="4251960"/>
-          </a:xfrm>
-          <a:prstGeom prst="roundRect">
-            <a:avLst/>
-          </a:prstGeom>
-          <a:solidFill>
-            <a:srgbClr val="143058"/>
-          </a:solidFill>
-          <a:ln>
-            <a:solidFill>
-              <a:srgbClr val="00B4B4"/>
-            </a:solidFill>
-          </a:ln>
-        </p:spPr>
-        <p:style>
-          <a:lnRef idx="1">
-            <a:schemeClr val="accent1"/>
-          </a:lnRef>
-          <a:fillRef idx="3">
-            <a:schemeClr val="accent1"/>
-          </a:fillRef>
-          <a:effectRef idx="2">
-            <a:schemeClr val="accent1"/>
-          </a:effectRef>
-          <a:fontRef idx="minor">
-            <a:schemeClr val="lt1"/>
-          </a:fontRef>
-        </p:style>
-        <p:txBody>
-          <a:bodyPr rtlCol="0" anchor="ctr"/>
-          <a:lstStyle/>
-          <a:p>
-            <a:pPr algn="ctr"/>
-          </a:p>
-        </p:txBody>
-      </p:sp>
+      <p:pic>
+        <p:nvPicPr>
+          <p:cNvPr id="5" name="Picture 4" descr="tradeoff_matrix.png"/>
+          <p:cNvPicPr>
+            <a:picLocks noChangeAspect="1"/>
+          </p:cNvPicPr>
+          <p:nvPr/>
+        </p:nvPicPr>
+        <p:blipFill>
+          <a:blip r:embed="rId2"/>
+          <a:stretch>
+            <a:fillRect/>
+          </a:stretch>
+        </p:blipFill>
+        <p:spPr>
+          <a:xfrm>
+            <a:off x="2883596" y="1481328"/>
+            <a:ext cx="6394327" cy="4782312"/>
+          </a:xfrm>
+          <a:prstGeom prst="rect">
+            <a:avLst/>
+          </a:prstGeom>
+        </p:spPr>
+      </p:pic>
       <p:sp>
         <p:nvSpPr>
           <p:cNvPr id="6" name="TextBox 5"/>
-          <p:cNvSpPr txBox="1"/>
-          <p:nvPr/>
-        </p:nvSpPr>
-        <p:spPr>
-          <a:xfrm>
-            <a:off x="960120" y="1920240"/>
-            <a:ext cx="4800600" cy="365760"/>
-          </a:xfrm>
-          <a:prstGeom prst="rect">
-            <a:avLst/>
-          </a:prstGeom>
-          <a:noFill/>
-        </p:spPr>
-        <p:txBody>
-          <a:bodyPr wrap="square" anchor="t">
-            <a:spAutoFit/>
-          </a:bodyPr>
-          <a:lstStyle/>
-          <a:p>
-            <a:pPr algn="ctr">
-              <a:defRPr sz="2000" b="1">
-                <a:solidFill>
-                  <a:srgbClr val="00B4B4"/>
-                </a:solidFill>
-                <a:latin typeface="Aptos"/>
-              </a:defRPr>
-            </a:pPr>
-            <a:r>
-              <a:t>WHY XGBOOST</a:t>
-            </a:r>
-          </a:p>
-        </p:txBody>
-      </p:sp>
-      <p:sp>
-        <p:nvSpPr>
-          <p:cNvPr id="7" name="TextBox 6"/>
-          <p:cNvSpPr txBox="1"/>
-          <p:nvPr/>
-        </p:nvSpPr>
-        <p:spPr>
-          <a:xfrm>
-            <a:off x="1051560" y="2633472"/>
-            <a:ext cx="4617720" cy="3017520"/>
-          </a:xfrm>
-          <a:prstGeom prst="rect">
-            <a:avLst/>
-          </a:prstGeom>
-          <a:noFill/>
-        </p:spPr>
-        <p:txBody>
-          <a:bodyPr wrap="square" anchor="t">
-            <a:spAutoFit/>
-          </a:bodyPr>
-          <a:lstStyle/>
-          <a:p>
-            <a:pPr algn="ctr">
-              <a:defRPr sz="1500" b="0">
-                <a:solidFill>
-                  <a:srgbClr val="F0F4F8"/>
-                </a:solidFill>
-                <a:latin typeface="Aptos"/>
-              </a:defRPr>
-            </a:pPr>
-            <a:r>
-              <a:t>Competitive probability loss</a:t>
-            </a:r>
-            <a:br/>
-            <a:br/>
-            <a:r>
-              <a:t>Audit subgroup errors</a:t>
-            </a:r>
-            <a:br/>
-            <a:br/>
-            <a:r>
-              <a:t>SHAP explanations available</a:t>
-            </a:r>
-            <a:br/>
-            <a:br/>
-            <a:r>
-              <a:t>Low inference cost</a:t>
-            </a:r>
-          </a:p>
-        </p:txBody>
-      </p:sp>
-      <p:sp>
-        <p:nvSpPr>
-          <p:cNvPr id="8" name="Rounded Rectangle 7"/>
-          <p:cNvSpPr/>
-          <p:nvPr/>
-        </p:nvSpPr>
-        <p:spPr>
-          <a:xfrm>
-            <a:off x="6217920" y="1645920"/>
-            <a:ext cx="5257800" cy="4251960"/>
-          </a:xfrm>
-          <a:prstGeom prst="roundRect">
-            <a:avLst/>
-          </a:prstGeom>
-          <a:solidFill>
-            <a:srgbClr val="143058"/>
-          </a:solidFill>
-          <a:ln>
-            <a:solidFill>
-              <a:srgbClr val="7B2CBF"/>
-            </a:solidFill>
-          </a:ln>
-        </p:spPr>
-        <p:style>
-          <a:lnRef idx="1">
-            <a:schemeClr val="accent1"/>
-          </a:lnRef>
-          <a:fillRef idx="3">
-            <a:schemeClr val="accent1"/>
-          </a:fillRef>
-          <a:effectRef idx="2">
-            <a:schemeClr val="accent1"/>
-          </a:effectRef>
-          <a:fontRef idx="minor">
-            <a:schemeClr val="lt1"/>
-          </a:fontRef>
-        </p:style>
-        <p:txBody>
-          <a:bodyPr rtlCol="0" anchor="ctr"/>
-          <a:lstStyle/>
-          <a:p>
-            <a:pPr algn="ctr"/>
-          </a:p>
-        </p:txBody>
-      </p:sp>
-      <p:sp>
-        <p:nvSpPr>
-          <p:cNvPr id="9" name="TextBox 8"/>
-          <p:cNvSpPr txBox="1"/>
-          <p:nvPr/>
-        </p:nvSpPr>
-        <p:spPr>
-          <a:xfrm>
-            <a:off x="6446520" y="1920240"/>
-            <a:ext cx="4800600" cy="365760"/>
-          </a:xfrm>
-          <a:prstGeom prst="rect">
-            <a:avLst/>
-          </a:prstGeom>
-          <a:noFill/>
-        </p:spPr>
-        <p:txBody>
-          <a:bodyPr wrap="square" anchor="t">
-            <a:spAutoFit/>
-          </a:bodyPr>
-          <a:lstStyle/>
-          <a:p>
-            <a:pPr algn="ctr">
-              <a:defRPr sz="2000" b="1">
-                <a:solidFill>
-                  <a:srgbClr val="7B2CBF"/>
-                </a:solidFill>
-                <a:latin typeface="Aptos"/>
-              </a:defRPr>
-            </a:pPr>
-            <a:r>
-              <a:t>CONDITIONS</a:t>
-            </a:r>
-          </a:p>
-        </p:txBody>
-      </p:sp>
-      <p:sp>
-        <p:nvSpPr>
-          <p:cNvPr id="10" name="TextBox 9"/>
-          <p:cNvSpPr txBox="1"/>
-          <p:nvPr/>
-        </p:nvSpPr>
-        <p:spPr>
-          <a:xfrm>
-            <a:off x="6537959" y="2633472"/>
-            <a:ext cx="4617720" cy="3017520"/>
-          </a:xfrm>
-          <a:prstGeom prst="rect">
-            <a:avLst/>
-          </a:prstGeom>
-          <a:noFill/>
-        </p:spPr>
-        <p:txBody>
-          <a:bodyPr wrap="square" anchor="t">
-            <a:spAutoFit/>
-          </a:bodyPr>
-          <a:lstStyle/>
-          <a:p>
-            <a:pPr algn="ctr">
-              <a:defRPr sz="1500" b="0">
-                <a:solidFill>
-                  <a:srgbClr val="F0F4F8"/>
-                </a:solidFill>
-                <a:latin typeface="Aptos"/>
-              </a:defRPr>
-            </a:pPr>
-            <a:r>
-              <a:t>Benefit-only allocation</a:t>
-            </a:r>
-            <a:br/>
-            <a:br/>
-            <a:r>
-              <a:t>Logistic as transparent challenger</a:t>
-            </a:r>
-            <a:br/>
-            <a:br/>
-            <a:r>
-              <a:t>Prospective shadow validation</a:t>
-            </a:r>
-            <a:br/>
-            <a:br/>
-            <a:r>
-              <a:t>Appeal route, logs, quarterly audits, stop rules</a:t>
-            </a:r>
-          </a:p>
-        </p:txBody>
-      </p:sp>
-      <p:sp>
-        <p:nvSpPr>
-          <p:cNvPr id="11" name="TextBox 10"/>
           <p:cNvSpPr txBox="1"/>
           <p:nvPr/>
         </p:nvSpPr>
@@ -5937,7 +5974,7 @@
       </p:sp>
       <p:sp>
         <p:nvSpPr>
-          <p:cNvPr id="12" name="TextBox 11"/>
+          <p:cNvPr id="7" name="TextBox 6"/>
           <p:cNvSpPr txBox="1"/>
           <p:nvPr/>
         </p:nvSpPr>
@@ -6028,7 +6065,484 @@
               </a:defRPr>
             </a:pPr>
             <a:r>
-              <a:t>15 · CLIENT EXPERIENCE</a:t>
+              <a:t>15 · RECOMMENDATION</a:t>
+            </a:r>
+          </a:p>
+        </p:txBody>
+      </p:sp>
+      <p:sp>
+        <p:nvSpPr>
+          <p:cNvPr id="3" name="TextBox 2"/>
+          <p:cNvSpPr txBox="1"/>
+          <p:nvPr/>
+        </p:nvSpPr>
+        <p:spPr>
+          <a:xfrm>
+            <a:off x="594360" y="621792"/>
+            <a:ext cx="10972800" cy="594360"/>
+          </a:xfrm>
+          <a:prstGeom prst="rect">
+            <a:avLst/>
+          </a:prstGeom>
+          <a:noFill/>
+        </p:spPr>
+        <p:txBody>
+          <a:bodyPr wrap="square" anchor="t">
+            <a:spAutoFit/>
+          </a:bodyPr>
+          <a:lstStyle/>
+          <a:p>
+            <a:pPr algn="l">
+              <a:defRPr sz="2600" b="1">
+                <a:solidFill>
+                  <a:srgbClr val="FFFFFF"/>
+                </a:solidFill>
+                <a:latin typeface="Aptos"/>
+              </a:defRPr>
+            </a:pPr>
+            <a:r>
+              <a:t>Pilot XGBoost; retain logistic as a transparent challenger</a:t>
+            </a:r>
+          </a:p>
+        </p:txBody>
+      </p:sp>
+      <p:sp>
+        <p:nvSpPr>
+          <p:cNvPr id="4" name="Rectangle 3"/>
+          <p:cNvSpPr/>
+          <p:nvPr/>
+        </p:nvSpPr>
+        <p:spPr>
+          <a:xfrm>
+            <a:off x="594360" y="1298448"/>
+            <a:ext cx="1005840" cy="50292"/>
+          </a:xfrm>
+          <a:prstGeom prst="rect">
+            <a:avLst/>
+          </a:prstGeom>
+          <a:solidFill>
+            <a:srgbClr val="FB8500"/>
+          </a:solidFill>
+          <a:ln>
+            <a:noFill/>
+          </a:ln>
+        </p:spPr>
+        <p:style>
+          <a:lnRef idx="1">
+            <a:schemeClr val="accent1"/>
+          </a:lnRef>
+          <a:fillRef idx="3">
+            <a:schemeClr val="accent1"/>
+          </a:fillRef>
+          <a:effectRef idx="2">
+            <a:schemeClr val="accent1"/>
+          </a:effectRef>
+          <a:fontRef idx="minor">
+            <a:schemeClr val="lt1"/>
+          </a:fontRef>
+        </p:style>
+        <p:txBody>
+          <a:bodyPr rtlCol="0" anchor="ctr"/>
+          <a:lstStyle/>
+          <a:p>
+            <a:pPr algn="ctr"/>
+          </a:p>
+        </p:txBody>
+      </p:sp>
+      <p:sp>
+        <p:nvSpPr>
+          <p:cNvPr id="5" name="Rounded Rectangle 4"/>
+          <p:cNvSpPr/>
+          <p:nvPr/>
+        </p:nvSpPr>
+        <p:spPr>
+          <a:xfrm>
+            <a:off x="731520" y="1645920"/>
+            <a:ext cx="5257800" cy="4251960"/>
+          </a:xfrm>
+          <a:prstGeom prst="roundRect">
+            <a:avLst/>
+          </a:prstGeom>
+          <a:solidFill>
+            <a:srgbClr val="143058"/>
+          </a:solidFill>
+          <a:ln>
+            <a:solidFill>
+              <a:srgbClr val="00B4B4"/>
+            </a:solidFill>
+          </a:ln>
+        </p:spPr>
+        <p:style>
+          <a:lnRef idx="1">
+            <a:schemeClr val="accent1"/>
+          </a:lnRef>
+          <a:fillRef idx="3">
+            <a:schemeClr val="accent1"/>
+          </a:fillRef>
+          <a:effectRef idx="2">
+            <a:schemeClr val="accent1"/>
+          </a:effectRef>
+          <a:fontRef idx="minor">
+            <a:schemeClr val="lt1"/>
+          </a:fontRef>
+        </p:style>
+        <p:txBody>
+          <a:bodyPr rtlCol="0" anchor="ctr"/>
+          <a:lstStyle/>
+          <a:p>
+            <a:pPr algn="ctr"/>
+          </a:p>
+        </p:txBody>
+      </p:sp>
+      <p:sp>
+        <p:nvSpPr>
+          <p:cNvPr id="6" name="TextBox 5"/>
+          <p:cNvSpPr txBox="1"/>
+          <p:nvPr/>
+        </p:nvSpPr>
+        <p:spPr>
+          <a:xfrm>
+            <a:off x="960120" y="1920240"/>
+            <a:ext cx="4800600" cy="365760"/>
+          </a:xfrm>
+          <a:prstGeom prst="rect">
+            <a:avLst/>
+          </a:prstGeom>
+          <a:noFill/>
+        </p:spPr>
+        <p:txBody>
+          <a:bodyPr wrap="square" anchor="t">
+            <a:spAutoFit/>
+          </a:bodyPr>
+          <a:lstStyle/>
+          <a:p>
+            <a:pPr algn="ctr">
+              <a:defRPr sz="2000" b="1">
+                <a:solidFill>
+                  <a:srgbClr val="00B4B4"/>
+                </a:solidFill>
+                <a:latin typeface="Aptos"/>
+              </a:defRPr>
+            </a:pPr>
+            <a:r>
+              <a:t>WHY XGBOOST</a:t>
+            </a:r>
+          </a:p>
+        </p:txBody>
+      </p:sp>
+      <p:sp>
+        <p:nvSpPr>
+          <p:cNvPr id="7" name="TextBox 6"/>
+          <p:cNvSpPr txBox="1"/>
+          <p:nvPr/>
+        </p:nvSpPr>
+        <p:spPr>
+          <a:xfrm>
+            <a:off x="1051560" y="2633472"/>
+            <a:ext cx="4617720" cy="3017520"/>
+          </a:xfrm>
+          <a:prstGeom prst="rect">
+            <a:avLst/>
+          </a:prstGeom>
+          <a:noFill/>
+        </p:spPr>
+        <p:txBody>
+          <a:bodyPr wrap="square" anchor="t">
+            <a:spAutoFit/>
+          </a:bodyPr>
+          <a:lstStyle/>
+          <a:p>
+            <a:pPr algn="ctr">
+              <a:defRPr sz="1500" b="0">
+                <a:solidFill>
+                  <a:srgbClr val="F0F4F8"/>
+                </a:solidFill>
+                <a:latin typeface="Aptos"/>
+              </a:defRPr>
+            </a:pPr>
+            <a:r>
+              <a:t>Competitive probability loss</a:t>
+            </a:r>
+            <a:br/>
+            <a:br/>
+            <a:r>
+              <a:t>Audit subgroup errors</a:t>
+            </a:r>
+            <a:br/>
+            <a:br/>
+            <a:r>
+              <a:t>SHAP explanations available</a:t>
+            </a:r>
+            <a:br/>
+            <a:br/>
+            <a:r>
+              <a:t>Low inference cost</a:t>
+            </a:r>
+          </a:p>
+        </p:txBody>
+      </p:sp>
+      <p:sp>
+        <p:nvSpPr>
+          <p:cNvPr id="8" name="Rounded Rectangle 7"/>
+          <p:cNvSpPr/>
+          <p:nvPr/>
+        </p:nvSpPr>
+        <p:spPr>
+          <a:xfrm>
+            <a:off x="6217920" y="1645920"/>
+            <a:ext cx="5257800" cy="4251960"/>
+          </a:xfrm>
+          <a:prstGeom prst="roundRect">
+            <a:avLst/>
+          </a:prstGeom>
+          <a:solidFill>
+            <a:srgbClr val="143058"/>
+          </a:solidFill>
+          <a:ln>
+            <a:solidFill>
+              <a:srgbClr val="7B2CBF"/>
+            </a:solidFill>
+          </a:ln>
+        </p:spPr>
+        <p:style>
+          <a:lnRef idx="1">
+            <a:schemeClr val="accent1"/>
+          </a:lnRef>
+          <a:fillRef idx="3">
+            <a:schemeClr val="accent1"/>
+          </a:fillRef>
+          <a:effectRef idx="2">
+            <a:schemeClr val="accent1"/>
+          </a:effectRef>
+          <a:fontRef idx="minor">
+            <a:schemeClr val="lt1"/>
+          </a:fontRef>
+        </p:style>
+        <p:txBody>
+          <a:bodyPr rtlCol="0" anchor="ctr"/>
+          <a:lstStyle/>
+          <a:p>
+            <a:pPr algn="ctr"/>
+          </a:p>
+        </p:txBody>
+      </p:sp>
+      <p:sp>
+        <p:nvSpPr>
+          <p:cNvPr id="9" name="TextBox 8"/>
+          <p:cNvSpPr txBox="1"/>
+          <p:nvPr/>
+        </p:nvSpPr>
+        <p:spPr>
+          <a:xfrm>
+            <a:off x="6446520" y="1920240"/>
+            <a:ext cx="4800600" cy="365760"/>
+          </a:xfrm>
+          <a:prstGeom prst="rect">
+            <a:avLst/>
+          </a:prstGeom>
+          <a:noFill/>
+        </p:spPr>
+        <p:txBody>
+          <a:bodyPr wrap="square" anchor="t">
+            <a:spAutoFit/>
+          </a:bodyPr>
+          <a:lstStyle/>
+          <a:p>
+            <a:pPr algn="ctr">
+              <a:defRPr sz="2000" b="1">
+                <a:solidFill>
+                  <a:srgbClr val="7B2CBF"/>
+                </a:solidFill>
+                <a:latin typeface="Aptos"/>
+              </a:defRPr>
+            </a:pPr>
+            <a:r>
+              <a:t>CONDITIONS</a:t>
+            </a:r>
+          </a:p>
+        </p:txBody>
+      </p:sp>
+      <p:sp>
+        <p:nvSpPr>
+          <p:cNvPr id="10" name="TextBox 9"/>
+          <p:cNvSpPr txBox="1"/>
+          <p:nvPr/>
+        </p:nvSpPr>
+        <p:spPr>
+          <a:xfrm>
+            <a:off x="6537959" y="2633472"/>
+            <a:ext cx="4617720" cy="3017520"/>
+          </a:xfrm>
+          <a:prstGeom prst="rect">
+            <a:avLst/>
+          </a:prstGeom>
+          <a:noFill/>
+        </p:spPr>
+        <p:txBody>
+          <a:bodyPr wrap="square" anchor="t">
+            <a:spAutoFit/>
+          </a:bodyPr>
+          <a:lstStyle/>
+          <a:p>
+            <a:pPr algn="ctr">
+              <a:defRPr sz="1500" b="0">
+                <a:solidFill>
+                  <a:srgbClr val="F0F4F8"/>
+                </a:solidFill>
+                <a:latin typeface="Aptos"/>
+              </a:defRPr>
+            </a:pPr>
+            <a:r>
+              <a:t>Benefit-only allocation</a:t>
+            </a:r>
+            <a:br/>
+            <a:br/>
+            <a:r>
+              <a:t>Logistic as transparent challenger</a:t>
+            </a:r>
+            <a:br/>
+            <a:br/>
+            <a:r>
+              <a:t>Prospective shadow validation</a:t>
+            </a:r>
+            <a:br/>
+            <a:br/>
+            <a:r>
+              <a:t>Appeal route, logs, quarterly audits, stop rules</a:t>
+            </a:r>
+          </a:p>
+        </p:txBody>
+      </p:sp>
+      <p:sp>
+        <p:nvSpPr>
+          <p:cNvPr id="11" name="TextBox 10"/>
+          <p:cNvSpPr txBox="1"/>
+          <p:nvPr/>
+        </p:nvSpPr>
+        <p:spPr>
+          <a:xfrm>
+            <a:off x="594360" y="6510528"/>
+            <a:ext cx="3657600" cy="164592"/>
+          </a:xfrm>
+          <a:prstGeom prst="rect">
+            <a:avLst/>
+          </a:prstGeom>
+          <a:noFill/>
+        </p:spPr>
+        <p:txBody>
+          <a:bodyPr wrap="square" anchor="t">
+            <a:spAutoFit/>
+          </a:bodyPr>
+          <a:lstStyle/>
+          <a:p>
+            <a:pPr algn="l">
+              <a:defRPr sz="800" b="0">
+                <a:solidFill>
+                  <a:srgbClr val="828FA0"/>
+                </a:solidFill>
+                <a:latin typeface="Aptos"/>
+              </a:defRPr>
+            </a:pPr>
+            <a:r>
+              <a:t>HEC Paris · ISAF · 2026</a:t>
+            </a:r>
+          </a:p>
+        </p:txBody>
+      </p:sp>
+      <p:sp>
+        <p:nvSpPr>
+          <p:cNvPr id="12" name="TextBox 11"/>
+          <p:cNvSpPr txBox="1"/>
+          <p:nvPr/>
+        </p:nvSpPr>
+        <p:spPr>
+          <a:xfrm>
+            <a:off x="11109960" y="6492240"/>
+            <a:ext cx="411480" cy="164592"/>
+          </a:xfrm>
+          <a:prstGeom prst="rect">
+            <a:avLst/>
+          </a:prstGeom>
+          <a:noFill/>
+        </p:spPr>
+        <p:txBody>
+          <a:bodyPr wrap="square" anchor="t">
+            <a:spAutoFit/>
+          </a:bodyPr>
+          <a:lstStyle/>
+          <a:p>
+            <a:pPr algn="r">
+              <a:defRPr sz="800" b="0">
+                <a:solidFill>
+                  <a:srgbClr val="828FA0"/>
+                </a:solidFill>
+                <a:latin typeface="Aptos"/>
+              </a:defRPr>
+            </a:pPr>
+            <a:r>
+              <a:t>16</a:t>
+            </a:r>
+          </a:p>
+        </p:txBody>
+      </p:sp>
+    </p:spTree>
+  </p:cSld>
+  <p:clrMapOvr>
+    <a:masterClrMapping/>
+  </p:clrMapOvr>
+</p:sld>
+</file>
+
+<file path=ppt/slides/slide17.xml><?xml version="1.0" encoding="utf-8"?>
+<p:sld xmlns:a="http://schemas.openxmlformats.org/drawingml/2006/main" xmlns:p="http://schemas.openxmlformats.org/presentationml/2006/main" xmlns:r="http://schemas.openxmlformats.org/officeDocument/2006/relationships">
+  <p:cSld>
+    <p:bg>
+      <p:bgPr>
+        <a:solidFill>
+          <a:srgbClr val="0A1F44"/>
+        </a:solidFill>
+        <a:effectLst/>
+      </p:bgPr>
+    </p:bg>
+    <p:spTree>
+      <p:nvGrpSpPr>
+        <p:cNvPr id="1" name=""/>
+        <p:cNvGrpSpPr/>
+        <p:nvPr/>
+      </p:nvGrpSpPr>
+      <p:grpSpPr/>
+      <p:sp>
+        <p:nvSpPr>
+          <p:cNvPr id="2" name="TextBox 1"/>
+          <p:cNvSpPr txBox="1"/>
+          <p:nvPr/>
+        </p:nvSpPr>
+        <p:spPr>
+          <a:xfrm>
+            <a:off x="594360" y="256032"/>
+            <a:ext cx="10972800" cy="274320"/>
+          </a:xfrm>
+          <a:prstGeom prst="rect">
+            <a:avLst/>
+          </a:prstGeom>
+          <a:noFill/>
+        </p:spPr>
+        <p:txBody>
+          <a:bodyPr wrap="square" anchor="t">
+            <a:spAutoFit/>
+          </a:bodyPr>
+          <a:lstStyle/>
+          <a:p>
+            <a:pPr algn="l">
+              <a:defRPr sz="1000" b="1">
+                <a:solidFill>
+                  <a:srgbClr val="FB8500"/>
+                </a:solidFill>
+                <a:latin typeface="Aptos"/>
+              </a:defRPr>
+            </a:pPr>
+            <a:r>
+              <a:t>16 · CLIENT EXPERIENCE</a:t>
             </a:r>
           </a:p>
         </p:txBody>
@@ -6341,7 +6855,7 @@
               </a:defRPr>
             </a:pPr>
             <a:r>
-              <a:t>Race + gender, at the deployed point</a:t>
+              <a:t>Race, gender, age at the deployed point + FPDP</a:t>
             </a:r>
           </a:p>
         </p:txBody>
@@ -6683,7 +7197,7 @@
               </a:defRPr>
             </a:pPr>
             <a:r>
-              <a:t>16</a:t>
+              <a:t>17</a:t>
             </a:r>
           </a:p>
         </p:txBody>
@@ -9469,7 +9983,7 @@
               </a:defRPr>
             </a:pPr>
             <a:r>
-              <a:t>0.0112</a:t>
+              <a:t>+0.0025</a:t>
             </a:r>
           </a:p>
         </p:txBody>
@@ -9505,7 +10019,7 @@
               </a:defRPr>
             </a:pPr>
             <a:r>
-              <a:t>ECE · XGBOOST</a:t>
+              <a:t>AUC GAP · XGB − LOGIT</a:t>
             </a:r>
           </a:p>
         </p:txBody>
@@ -9513,6 +10027,42 @@
       <p:sp>
         <p:nvSpPr>
           <p:cNvPr id="15" name="TextBox 14"/>
+          <p:cNvSpPr txBox="1"/>
+          <p:nvPr/>
+        </p:nvSpPr>
+        <p:spPr>
+          <a:xfrm>
+            <a:off x="8567928" y="5632704"/>
+            <a:ext cx="2194560" cy="164592"/>
+          </a:xfrm>
+          <a:prstGeom prst="rect">
+            <a:avLst/>
+          </a:prstGeom>
+          <a:noFill/>
+        </p:spPr>
+        <p:txBody>
+          <a:bodyPr wrap="square" anchor="t">
+            <a:spAutoFit/>
+          </a:bodyPr>
+          <a:lstStyle/>
+          <a:p>
+            <a:pPr algn="ctr">
+              <a:defRPr sz="800" b="0">
+                <a:solidFill>
+                  <a:srgbClr val="F0F4F8"/>
+                </a:solidFill>
+                <a:latin typeface="Aptos"/>
+              </a:defRPr>
+            </a:pPr>
+            <a:r>
+              <a:t>paired bootstrap: significant, small</a:t>
+            </a:r>
+          </a:p>
+        </p:txBody>
+      </p:sp>
+      <p:sp>
+        <p:nvSpPr>
+          <p:cNvPr id="16" name="TextBox 15"/>
           <p:cNvSpPr txBox="1"/>
           <p:nvPr/>
         </p:nvSpPr>
@@ -9541,14 +10091,14 @@
               </a:defRPr>
             </a:pPr>
             <a:r>
-              <a:t>Paired bootstrap compares differences directly; see paired_comparisons.csv. Results remain exploratory.</a:t>
-            </a:r>
-          </a:p>
-        </p:txBody>
-      </p:sp>
-      <p:sp>
-        <p:nvSpPr>
-          <p:cNvPr id="16" name="TextBox 15"/>
+              <a:t>All three models are within ~0.003 AUC; ECE differences are not significant. Performance alone cannot pick the model.</a:t>
+            </a:r>
+          </a:p>
+        </p:txBody>
+      </p:sp>
+      <p:sp>
+        <p:nvSpPr>
+          <p:cNvPr id="17" name="TextBox 16"/>
           <p:cNvSpPr txBox="1"/>
           <p:nvPr/>
         </p:nvSpPr>
@@ -9584,7 +10134,7 @@
       </p:sp>
       <p:sp>
         <p:nvSpPr>
-          <p:cNvPr id="17" name="TextBox 16"/>
+          <p:cNvPr id="18" name="TextBox 17"/>
           <p:cNvSpPr txBox="1"/>
           <p:nvPr/>
         </p:nvSpPr>

</xml_diff>

<commit_message>
Verify end-to-end reproducibility, GPU execution and paired stability
</commit_message>
<xml_diff>
--- a/reports/ISAF_Recidivism_Presentation.pptx
+++ b/reports/ISAF_Recidivism_Presentation.pptx
@@ -3571,7 +3571,7 @@
           </a:solidFill>
           <a:ln>
             <a:solidFill>
-              <a:srgbClr val="D64343"/>
+              <a:srgbClr val="7B2CBF"/>
             </a:solidFill>
           </a:ln>
         </p:spPr>
@@ -3622,13 +3622,13 @@
             <a:pPr algn="ctr">
               <a:defRPr sz="2400" b="1">
                 <a:solidFill>
-                  <a:srgbClr val="D64343"/>
-                </a:solidFill>
-                <a:latin typeface="Aptos"/>
-              </a:defRPr>
-            </a:pPr>
-            <a:r>
-              <a:t>0.036</a:t>
+                  <a:srgbClr val="7B2CBF"/>
+                </a:solidFill>
+                <a:latin typeface="Aptos"/>
+              </a:defRPr>
+            </a:pPr>
+            <a:r>
+              <a:t>0.035</a:t>
             </a:r>
           </a:p>
         </p:txBody>
@@ -3688,7 +3688,7 @@
           </a:solidFill>
           <a:ln>
             <a:solidFill>
-              <a:srgbClr val="FB8500"/>
+              <a:srgbClr val="00B4B4"/>
             </a:solidFill>
           </a:ln>
         </p:spPr>
@@ -3739,13 +3739,13 @@
             <a:pPr algn="ctr">
               <a:defRPr sz="2400" b="1">
                 <a:solidFill>
-                  <a:srgbClr val="FB8500"/>
-                </a:solidFill>
-                <a:latin typeface="Aptos"/>
-              </a:defRPr>
-            </a:pPr>
-            <a:r>
-              <a:t>77.0%</a:t>
+                  <a:srgbClr val="00B4B4"/>
+                </a:solidFill>
+                <a:latin typeface="Aptos"/>
+              </a:defRPr>
+            </a:pPr>
+            <a:r>
+              <a:t>77.6%</a:t>
             </a:r>
           </a:p>
         </p:txBody>

</xml_diff>

<commit_message>
Write speaker notes into the deck
The talk sequence lived in presentation_notes.md, which is not open while
presenting. These go in the notes pane, so they appear in presenter view
and travel with the file.

One note per core slide: a running clock, what to say rather than what is
already on the slide, and the caveat to volunteer before a juror asks for
it. Slide 3 carries the leak and the adaptive-evaluation admission, slide
7 is marked to slow down, slide 10 explains why the nested check exists,
and slide 12 states plainly what the recommendation does not claim. Slide
13 ends with the appendix cues, so a question can be answered by jumping
to A1-A9 rather than hunting.

Notes come to about 1,550 words, roughly 12 minutes at a normal pace
against 14 minutes of allocated timings.

Co-Authored-By: Claude Opus 5 (1M context) <noreply@anthropic.com>
</commit_message>
<xml_diff>
--- a/reports/ISAF_Recidivism_Presentation.pptx
+++ b/reports/ISAF_Recidivism_Presentation.pptx
@@ -127,6 +127,1968 @@
     </a:lvl9pPr>
   </p:defaultTextStyle>
 </p:presentation>
+</file>
+
+<file path=ppt/notesMasters/notesMaster1.xml><?xml version="1.0" encoding="utf-8"?>
+<p:notesMaster xmlns:a="http://schemas.openxmlformats.org/drawingml/2006/main" xmlns:p="http://schemas.openxmlformats.org/presentationml/2006/main" xmlns:r="http://schemas.openxmlformats.org/officeDocument/2006/relationships">
+  <p:cSld>
+    <p:bg>
+      <p:bgRef idx="1001">
+        <a:schemeClr val="bg1"/>
+      </p:bgRef>
+    </p:bg>
+    <p:spTree>
+      <p:nvGrpSpPr>
+        <p:cNvPr id="1" name=""/>
+        <p:cNvGrpSpPr/>
+        <p:nvPr/>
+      </p:nvGrpSpPr>
+      <p:grpSpPr>
+        <a:xfrm>
+          <a:off x="0" y="0"/>
+          <a:ext cx="0" cy="0"/>
+          <a:chOff x="0" y="0"/>
+          <a:chExt cx="0" cy="0"/>
+        </a:xfrm>
+      </p:grpSpPr>
+      <p:sp>
+        <p:nvSpPr>
+          <p:cNvPr id="2" name="Header Placeholder 1"/>
+          <p:cNvSpPr>
+            <a:spLocks noGrp="1"/>
+          </p:cNvSpPr>
+          <p:nvPr>
+            <p:ph type="hdr" sz="quarter"/>
+          </p:nvPr>
+        </p:nvSpPr>
+        <p:spPr>
+          <a:xfrm>
+            <a:off x="0" y="0"/>
+            <a:ext cx="2971800" cy="457200"/>
+          </a:xfrm>
+          <a:prstGeom prst="rect">
+            <a:avLst/>
+          </a:prstGeom>
+        </p:spPr>
+        <p:txBody>
+          <a:bodyPr vert="horz" lIns="91440" tIns="45720" rIns="91440" bIns="45720" rtlCol="0"/>
+          <a:lstStyle>
+            <a:lvl1pPr algn="l">
+              <a:defRPr sz="1200"/>
+            </a:lvl1pPr>
+          </a:lstStyle>
+          <a:p>
+            <a:endParaRPr lang="en-US"/>
+          </a:p>
+        </p:txBody>
+      </p:sp>
+      <p:sp>
+        <p:nvSpPr>
+          <p:cNvPr id="3" name="Date Placeholder 2"/>
+          <p:cNvSpPr>
+            <a:spLocks noGrp="1"/>
+          </p:cNvSpPr>
+          <p:nvPr>
+            <p:ph type="dt" idx="1"/>
+          </p:nvPr>
+        </p:nvSpPr>
+        <p:spPr>
+          <a:xfrm>
+            <a:off x="3884613" y="0"/>
+            <a:ext cx="2971800" cy="457200"/>
+          </a:xfrm>
+          <a:prstGeom prst="rect">
+            <a:avLst/>
+          </a:prstGeom>
+        </p:spPr>
+        <p:txBody>
+          <a:bodyPr vert="horz" lIns="91440" tIns="45720" rIns="91440" bIns="45720" rtlCol="0"/>
+          <a:lstStyle>
+            <a:lvl1pPr algn="r">
+              <a:defRPr sz="1200"/>
+            </a:lvl1pPr>
+          </a:lstStyle>
+          <a:p>
+            <a:fld id="{0F89C1C7-3DCD-1040-A9CF-14679D8B5DDD}" type="datetimeFigureOut">
+              <a:rPr lang="en-US" smtClean="0"/>
+              <a:t>10/17/16</a:t>
+            </a:fld>
+            <a:endParaRPr lang="en-US"/>
+          </a:p>
+        </p:txBody>
+      </p:sp>
+      <p:sp>
+        <p:nvSpPr>
+          <p:cNvPr id="4" name="Slide Image Placeholder 3"/>
+          <p:cNvSpPr>
+            <a:spLocks noGrp="1" noRot="1" noChangeAspect="1"/>
+          </p:cNvSpPr>
+          <p:nvPr>
+            <p:ph type="sldImg" idx="2"/>
+          </p:nvPr>
+        </p:nvSpPr>
+        <p:spPr>
+          <a:xfrm>
+            <a:off x="1143000" y="685800"/>
+            <a:ext cx="4572000" cy="3429000"/>
+          </a:xfrm>
+          <a:prstGeom prst="rect">
+            <a:avLst/>
+          </a:prstGeom>
+          <a:noFill/>
+          <a:ln w="12700">
+            <a:solidFill>
+              <a:prstClr val="black"/>
+            </a:solidFill>
+          </a:ln>
+        </p:spPr>
+        <p:txBody>
+          <a:bodyPr vert="horz" lIns="91440" tIns="45720" rIns="91440" bIns="45720" rtlCol="0" anchor="ctr"/>
+          <a:lstStyle/>
+          <a:p>
+            <a:endParaRPr lang="en-US"/>
+          </a:p>
+        </p:txBody>
+      </p:sp>
+      <p:sp>
+        <p:nvSpPr>
+          <p:cNvPr id="5" name="Notes Placeholder 4"/>
+          <p:cNvSpPr>
+            <a:spLocks noGrp="1"/>
+          </p:cNvSpPr>
+          <p:nvPr>
+            <p:ph type="body" sz="quarter" idx="3"/>
+          </p:nvPr>
+        </p:nvSpPr>
+        <p:spPr>
+          <a:xfrm>
+            <a:off x="685800" y="4343400"/>
+            <a:ext cx="5486400" cy="4114800"/>
+          </a:xfrm>
+          <a:prstGeom prst="rect">
+            <a:avLst/>
+          </a:prstGeom>
+        </p:spPr>
+        <p:txBody>
+          <a:bodyPr vert="horz" lIns="91440" tIns="45720" rIns="91440" bIns="45720" rtlCol="0"/>
+          <a:lstStyle/>
+          <a:p>
+            <a:pPr lvl="0"/>
+            <a:r>
+              <a:rPr lang="en-US" smtClean="0"/>
+              <a:t>Click to edit Master text styles</a:t>
+            </a:r>
+          </a:p>
+          <a:p>
+            <a:pPr lvl="1"/>
+            <a:r>
+              <a:rPr lang="en-US" smtClean="0"/>
+              <a:t>Second level</a:t>
+            </a:r>
+          </a:p>
+          <a:p>
+            <a:pPr lvl="2"/>
+            <a:r>
+              <a:rPr lang="en-US" smtClean="0"/>
+              <a:t>Third level</a:t>
+            </a:r>
+          </a:p>
+          <a:p>
+            <a:pPr lvl="3"/>
+            <a:r>
+              <a:rPr lang="en-US" smtClean="0"/>
+              <a:t>Fourth level</a:t>
+            </a:r>
+          </a:p>
+          <a:p>
+            <a:pPr lvl="4"/>
+            <a:r>
+              <a:rPr lang="en-US" smtClean="0"/>
+              <a:t>Fifth level</a:t>
+            </a:r>
+            <a:endParaRPr lang="en-US"/>
+          </a:p>
+        </p:txBody>
+      </p:sp>
+      <p:sp>
+        <p:nvSpPr>
+          <p:cNvPr id="6" name="Footer Placeholder 5"/>
+          <p:cNvSpPr>
+            <a:spLocks noGrp="1"/>
+          </p:cNvSpPr>
+          <p:nvPr>
+            <p:ph type="ftr" sz="quarter" idx="4"/>
+          </p:nvPr>
+        </p:nvSpPr>
+        <p:spPr>
+          <a:xfrm>
+            <a:off x="0" y="8685213"/>
+            <a:ext cx="2971800" cy="457200"/>
+          </a:xfrm>
+          <a:prstGeom prst="rect">
+            <a:avLst/>
+          </a:prstGeom>
+        </p:spPr>
+        <p:txBody>
+          <a:bodyPr vert="horz" lIns="91440" tIns="45720" rIns="91440" bIns="45720" rtlCol="0" anchor="b"/>
+          <a:lstStyle>
+            <a:lvl1pPr algn="l">
+              <a:defRPr sz="1200"/>
+            </a:lvl1pPr>
+          </a:lstStyle>
+          <a:p>
+            <a:endParaRPr lang="en-US"/>
+          </a:p>
+        </p:txBody>
+      </p:sp>
+      <p:sp>
+        <p:nvSpPr>
+          <p:cNvPr id="7" name="Slide Number Placeholder 6"/>
+          <p:cNvSpPr>
+            <a:spLocks noGrp="1"/>
+          </p:cNvSpPr>
+          <p:nvPr>
+            <p:ph type="sldNum" sz="quarter" idx="5"/>
+          </p:nvPr>
+        </p:nvSpPr>
+        <p:spPr>
+          <a:xfrm>
+            <a:off x="3884613" y="8685213"/>
+            <a:ext cx="2971800" cy="457200"/>
+          </a:xfrm>
+          <a:prstGeom prst="rect">
+            <a:avLst/>
+          </a:prstGeom>
+        </p:spPr>
+        <p:txBody>
+          <a:bodyPr vert="horz" lIns="91440" tIns="45720" rIns="91440" bIns="45720" rtlCol="0" anchor="b"/>
+          <a:lstStyle>
+            <a:lvl1pPr algn="r">
+              <a:defRPr sz="1200"/>
+            </a:lvl1pPr>
+          </a:lstStyle>
+          <a:p>
+            <a:fld id="{BB5E49A5-4136-284D-997B-48E1D791AD67}" type="slidenum">
+              <a:rPr lang="en-US" smtClean="0"/>
+              <a:t>‹#›</a:t>
+            </a:fld>
+            <a:endParaRPr lang="en-US"/>
+          </a:p>
+        </p:txBody>
+      </p:sp>
+    </p:spTree>
+    <p:extLst>
+      <p:ext uri="{BB962C8B-B14F-4D97-AF65-F5344CB8AC3E}">
+        <p14:creationId xmlns:p14="http://schemas.microsoft.com/office/powerpoint/2010/main" val="2623252185"/>
+      </p:ext>
+    </p:extLst>
+  </p:cSld>
+  <p:clrMap bg1="lt1" tx1="dk1" bg2="lt2" tx2="dk2" accent1="accent1" accent2="accent2" accent3="accent3" accent4="accent4" accent5="accent5" accent6="accent6" hlink="hlink" folHlink="folHlink"/>
+  <p:notesStyle>
+    <a:lvl1pPr marL="0" algn="l" defTabSz="457200" rtl="0" eaLnBrk="1" latinLnBrk="0" hangingPunct="1">
+      <a:defRPr sz="1200" kern="1200">
+        <a:solidFill>
+          <a:schemeClr val="tx1"/>
+        </a:solidFill>
+        <a:latin typeface="+mn-lt"/>
+        <a:ea typeface="+mn-ea"/>
+        <a:cs typeface="+mn-cs"/>
+      </a:defRPr>
+    </a:lvl1pPr>
+    <a:lvl2pPr marL="457200" algn="l" defTabSz="457200" rtl="0" eaLnBrk="1" latinLnBrk="0" hangingPunct="1">
+      <a:defRPr sz="1200" kern="1200">
+        <a:solidFill>
+          <a:schemeClr val="tx1"/>
+        </a:solidFill>
+        <a:latin typeface="+mn-lt"/>
+        <a:ea typeface="+mn-ea"/>
+        <a:cs typeface="+mn-cs"/>
+      </a:defRPr>
+    </a:lvl2pPr>
+    <a:lvl3pPr marL="914400" algn="l" defTabSz="457200" rtl="0" eaLnBrk="1" latinLnBrk="0" hangingPunct="1">
+      <a:defRPr sz="1200" kern="1200">
+        <a:solidFill>
+          <a:schemeClr val="tx1"/>
+        </a:solidFill>
+        <a:latin typeface="+mn-lt"/>
+        <a:ea typeface="+mn-ea"/>
+        <a:cs typeface="+mn-cs"/>
+      </a:defRPr>
+    </a:lvl3pPr>
+    <a:lvl4pPr marL="1371600" algn="l" defTabSz="457200" rtl="0" eaLnBrk="1" latinLnBrk="0" hangingPunct="1">
+      <a:defRPr sz="1200" kern="1200">
+        <a:solidFill>
+          <a:schemeClr val="tx1"/>
+        </a:solidFill>
+        <a:latin typeface="+mn-lt"/>
+        <a:ea typeface="+mn-ea"/>
+        <a:cs typeface="+mn-cs"/>
+      </a:defRPr>
+    </a:lvl4pPr>
+    <a:lvl5pPr marL="1828800" algn="l" defTabSz="457200" rtl="0" eaLnBrk="1" latinLnBrk="0" hangingPunct="1">
+      <a:defRPr sz="1200" kern="1200">
+        <a:solidFill>
+          <a:schemeClr val="tx1"/>
+        </a:solidFill>
+        <a:latin typeface="+mn-lt"/>
+        <a:ea typeface="+mn-ea"/>
+        <a:cs typeface="+mn-cs"/>
+      </a:defRPr>
+    </a:lvl5pPr>
+    <a:lvl6pPr marL="2286000" algn="l" defTabSz="457200" rtl="0" eaLnBrk="1" latinLnBrk="0" hangingPunct="1">
+      <a:defRPr sz="1200" kern="1200">
+        <a:solidFill>
+          <a:schemeClr val="tx1"/>
+        </a:solidFill>
+        <a:latin typeface="+mn-lt"/>
+        <a:ea typeface="+mn-ea"/>
+        <a:cs typeface="+mn-cs"/>
+      </a:defRPr>
+    </a:lvl6pPr>
+    <a:lvl7pPr marL="2743200" algn="l" defTabSz="457200" rtl="0" eaLnBrk="1" latinLnBrk="0" hangingPunct="1">
+      <a:defRPr sz="1200" kern="1200">
+        <a:solidFill>
+          <a:schemeClr val="tx1"/>
+        </a:solidFill>
+        <a:latin typeface="+mn-lt"/>
+        <a:ea typeface="+mn-ea"/>
+        <a:cs typeface="+mn-cs"/>
+      </a:defRPr>
+    </a:lvl7pPr>
+    <a:lvl8pPr marL="3200400" algn="l" defTabSz="457200" rtl="0" eaLnBrk="1" latinLnBrk="0" hangingPunct="1">
+      <a:defRPr sz="1200" kern="1200">
+        <a:solidFill>
+          <a:schemeClr val="tx1"/>
+        </a:solidFill>
+        <a:latin typeface="+mn-lt"/>
+        <a:ea typeface="+mn-ea"/>
+        <a:cs typeface="+mn-cs"/>
+      </a:defRPr>
+    </a:lvl8pPr>
+    <a:lvl9pPr marL="3657600" algn="l" defTabSz="457200" rtl="0" eaLnBrk="1" latinLnBrk="0" hangingPunct="1">
+      <a:defRPr sz="1200" kern="1200">
+        <a:solidFill>
+          <a:schemeClr val="tx1"/>
+        </a:solidFill>
+        <a:latin typeface="+mn-lt"/>
+        <a:ea typeface="+mn-ea"/>
+        <a:cs typeface="+mn-cs"/>
+      </a:defRPr>
+    </a:lvl9pPr>
+  </p:notesStyle>
+</p:notesMaster>
+</file>
+
+<file path=ppt/notesSlides/notesSlide1.xml><?xml version="1.0" encoding="utf-8"?>
+<p:notes xmlns:a="http://schemas.openxmlformats.org/drawingml/2006/main" xmlns:p="http://schemas.openxmlformats.org/presentationml/2006/main" xmlns:r="http://schemas.openxmlformats.org/officeDocument/2006/relationships">
+  <p:cSld>
+    <p:spTree>
+      <p:nvGrpSpPr>
+        <p:cNvPr id="1" name=""/>
+        <p:cNvGrpSpPr/>
+        <p:nvPr/>
+      </p:nvGrpSpPr>
+      <p:grpSpPr>
+        <a:xfrm>
+          <a:off x="0" y="0"/>
+          <a:ext cx="0" cy="0"/>
+          <a:chOff x="0" y="0"/>
+          <a:chExt cx="0" cy="0"/>
+        </a:xfrm>
+      </p:grpSpPr>
+      <p:sp>
+        <p:nvSpPr>
+          <p:cNvPr id="2" name="Slide Image Placeholder 1"/>
+          <p:cNvSpPr>
+            <a:spLocks noGrp="1"/>
+          </p:cNvSpPr>
+          <p:nvPr>
+            <p:ph type="sldImg" idx="2"/>
+          </p:nvPr>
+        </p:nvSpPr>
+        <p:spPr/>
+      </p:sp>
+      <p:sp>
+        <p:nvSpPr>
+          <p:cNvPr id="3" name="Notes Placeholder 2"/>
+          <p:cNvSpPr>
+            <a:spLocks noGrp="1"/>
+          </p:cNvSpPr>
+          <p:nvPr>
+            <p:ph type="body" idx="3" sz="quarter"/>
+          </p:nvPr>
+        </p:nvSpPr>
+        <p:spPr/>
+        <p:txBody>
+          <a:bodyPr/>
+          <a:lstStyle/>
+          <a:p>
+            <a:r>
+              <a:t>[0:00 · 30s] Opening.</a:t>
+            </a:r>
+          </a:p>
+          <a:p/>
+          <a:p>
+            <a:r>
+              <a:t>Team 11. Our client is a software vendor selling risk-assessment tools to US</a:t>
+            </a:r>
+          </a:p>
+          <a:p>
+            <a:r>
+              <a:t>community-supervision agencies. The question they brought us: which three-year</a:t>
+            </a:r>
+          </a:p>
+          <a:p>
+            <a:r>
+              <a:t>re-arrest model should they ship?</a:t>
+            </a:r>
+          </a:p>
+          <a:p/>
+          <a:p>
+            <a:r>
+              <a:t>Say the frame once, here: we judged four dimensions — performance,</a:t>
+            </a:r>
+          </a:p>
+          <a:p>
+            <a:r>
+              <a:t>interpretability, stability, fairness — not accuracy. The 0.60 to 0.73 on the</a:t>
+            </a:r>
+          </a:p>
+          <a:p>
+            <a:r>
+              <a:t>right is our models against the score agencies already have on file.</a:t>
+            </a:r>
+          </a:p>
+        </p:txBody>
+      </p:sp>
+      <p:sp>
+        <p:nvSpPr>
+          <p:cNvPr id="4" name="Slide Number Placeholder 3"/>
+          <p:cNvSpPr>
+            <a:spLocks noGrp="1"/>
+          </p:cNvSpPr>
+          <p:nvPr>
+            <p:ph type="sldNum" idx="5" sz="quarter"/>
+          </p:nvPr>
+        </p:nvSpPr>
+        <p:spPr/>
+      </p:sp>
+    </p:spTree>
+  </p:cSld>
+  <p:clrMapOvr>
+    <a:masterClrMapping/>
+  </p:clrMapOvr>
+</p:notes>
+</file>
+
+<file path=ppt/notesSlides/notesSlide10.xml><?xml version="1.0" encoding="utf-8"?>
+<p:notes xmlns:a="http://schemas.openxmlformats.org/drawingml/2006/main" xmlns:p="http://schemas.openxmlformats.org/presentationml/2006/main" xmlns:r="http://schemas.openxmlformats.org/officeDocument/2006/relationships">
+  <p:cSld>
+    <p:spTree>
+      <p:nvGrpSpPr>
+        <p:cNvPr id="1" name=""/>
+        <p:cNvGrpSpPr/>
+        <p:nvPr/>
+      </p:nvGrpSpPr>
+      <p:grpSpPr>
+        <a:xfrm>
+          <a:off x="0" y="0"/>
+          <a:ext cx="0" cy="0"/>
+          <a:chOff x="0" y="0"/>
+          <a:chExt cx="0" cy="0"/>
+        </a:xfrm>
+      </p:grpSpPr>
+      <p:sp>
+        <p:nvSpPr>
+          <p:cNvPr id="2" name="Slide Image Placeholder 1"/>
+          <p:cNvSpPr>
+            <a:spLocks noGrp="1"/>
+          </p:cNvSpPr>
+          <p:nvPr>
+            <p:ph type="sldImg" idx="2"/>
+          </p:nvPr>
+        </p:nvSpPr>
+        <p:spPr/>
+      </p:sp>
+      <p:sp>
+        <p:nvSpPr>
+          <p:cNvPr id="3" name="Notes Placeholder 2"/>
+          <p:cNvSpPr>
+            <a:spLocks noGrp="1"/>
+          </p:cNvSpPr>
+          <p:nvPr>
+            <p:ph type="body" idx="3" sz="quarter"/>
+          </p:nvPr>
+        </p:nvSpPr>
+        <p:spPr/>
+        <p:txBody>
+          <a:bodyPr/>
+          <a:lstStyle/>
+          <a:p>
+            <a:r>
+              <a:t>[10:15 · 1m00s] Did the fix generalise, or did we just fit it?</a:t>
+            </a:r>
+          </a:p>
+          <a:p/>
+          <a:p>
+            <a:r>
+              <a:t>This is the slide that separates us from a project that stops at the p-value.</a:t>
+            </a:r>
+          </a:p>
+          <a:p/>
+          <a:p>
+            <a:r>
+              <a:t>The result on the previous slide chose the variable AND measured the improvement on</a:t>
+            </a:r>
+          </a:p>
+          <a:p>
+            <a:r>
+              <a:t>the same cohort. That is in-sample. It shows a mitigation can be FITTED, not that</a:t>
+            </a:r>
+          </a:p>
+          <a:p>
+            <a:r>
+              <a:t>it works.</a:t>
+            </a:r>
+          </a:p>
+          <a:p/>
+          <a:p>
+            <a:r>
+              <a:t>So we separated them. Five outer folds, entirely inside the training partition. In</a:t>
+            </a:r>
+          </a:p>
+          <a:p>
+            <a:r>
+              <a:t>each fold we rerun the candidate search on that fold's training part, pick from</a:t>
+            </a:r>
+          </a:p>
+          <a:p>
+            <a:r>
+              <a:t>there alone, refit there, and measure on the held-out fold. The evaluation cohort</a:t>
+            </a:r>
+          </a:p>
+          <a:p>
+            <a:r>
+              <a:t>is never touched.</a:t>
+            </a:r>
+          </a:p>
+          <a:p/>
+          <a:p>
+            <a:r>
+              <a:t>Gang affiliation is selected in all five folds, for both models. About 70% of the</a:t>
+            </a:r>
+          </a:p>
+          <a:p>
+            <a:r>
+              <a:t>gap closes out of fold, for roughly one AUC point. The equal-opportunity p-value</a:t>
+            </a:r>
+          </a:p>
+          <a:p>
+            <a:r>
+              <a:t>reaches 0.27, not the in-sample 0.99 — and two of five folds still reject.</a:t>
+            </a:r>
+          </a:p>
+          <a:p/>
+          <a:p>
+            <a:r>
+              <a:t>We report the out-of-fold numbers. The in-sample figure is an upper bound.</a:t>
+            </a:r>
+          </a:p>
+        </p:txBody>
+      </p:sp>
+      <p:sp>
+        <p:nvSpPr>
+          <p:cNvPr id="4" name="Slide Number Placeholder 3"/>
+          <p:cNvSpPr>
+            <a:spLocks noGrp="1"/>
+          </p:cNvSpPr>
+          <p:nvPr>
+            <p:ph type="sldNum" idx="5" sz="quarter"/>
+          </p:nvPr>
+        </p:nvSpPr>
+        <p:spPr/>
+      </p:sp>
+    </p:spTree>
+  </p:cSld>
+  <p:clrMapOvr>
+    <a:masterClrMapping/>
+  </p:clrMapOvr>
+</p:notes>
+</file>
+
+<file path=ppt/notesSlides/notesSlide11.xml><?xml version="1.0" encoding="utf-8"?>
+<p:notes xmlns:a="http://schemas.openxmlformats.org/drawingml/2006/main" xmlns:p="http://schemas.openxmlformats.org/presentationml/2006/main" xmlns:r="http://schemas.openxmlformats.org/officeDocument/2006/relationships">
+  <p:cSld>
+    <p:spTree>
+      <p:nvGrpSpPr>
+        <p:cNvPr id="1" name=""/>
+        <p:cNvGrpSpPr/>
+        <p:nvPr/>
+      </p:nvGrpSpPr>
+      <p:grpSpPr>
+        <a:xfrm>
+          <a:off x="0" y="0"/>
+          <a:ext cx="0" cy="0"/>
+          <a:chOff x="0" y="0"/>
+          <a:chExt cx="0" cy="0"/>
+        </a:xfrm>
+      </p:grpSpPr>
+      <p:sp>
+        <p:nvSpPr>
+          <p:cNvPr id="2" name="Slide Image Placeholder 1"/>
+          <p:cNvSpPr>
+            <a:spLocks noGrp="1"/>
+          </p:cNvSpPr>
+          <p:nvPr>
+            <p:ph type="sldImg" idx="2"/>
+          </p:nvPr>
+        </p:nvSpPr>
+        <p:spPr/>
+      </p:sp>
+      <p:sp>
+        <p:nvSpPr>
+          <p:cNvPr id="3" name="Notes Placeholder 2"/>
+          <p:cNvSpPr>
+            <a:spLocks noGrp="1"/>
+          </p:cNvSpPr>
+          <p:nvPr>
+            <p:ph type="body" idx="3" sz="quarter"/>
+          </p:nvPr>
+        </p:nvSpPr>
+        <p:spPr/>
+        <p:txBody>
+          <a:bodyPr/>
+          <a:lstStyle/>
+          <a:p>
+            <a:r>
+              <a:t>[11:15 · 1m00s] The four dimensions together.</a:t>
+            </a:r>
+          </a:p>
+          <a:p/>
+          <a:p>
+            <a:r>
+              <a:t>Read across the rows, not down the columns.</a:t>
+            </a:r>
+          </a:p>
+          <a:p/>
+          <a:p>
+            <a:r>
+              <a:t>Performance: separated by 0.003 AUC, and the only real calibration difference goes</a:t>
+            </a:r>
+          </a:p>
+          <a:p>
+            <a:r>
+              <a:t>AGAINST the model with the highest AUC.</a:t>
+            </a:r>
+          </a:p>
+          <a:p/>
+          <a:p>
+            <a:r>
+              <a:t>Interpretability: unambiguous, and the gaps are large.</a:t>
+            </a:r>
+          </a:p>
+          <a:p/>
+          <a:p>
+            <a:r>
+              <a:t>Stability: logistic drifts least on all 28 resample pairs.</a:t>
+            </a:r>
+          </a:p>
+          <a:p/>
+          <a:p>
+            <a:r>
+              <a:t>Fairness: the differences BETWEEN models are smaller than they look. The gender and</a:t>
+            </a:r>
+          </a:p>
+          <a:p>
+            <a:r>
+              <a:t>age gaps are shared by all three.</a:t>
+            </a:r>
+          </a:p>
+          <a:p/>
+          <a:p>
+            <a:r>
+              <a:t>That is the shape of the decision: accuracy does not discriminate here.</a:t>
+            </a:r>
+          </a:p>
+        </p:txBody>
+      </p:sp>
+      <p:sp>
+        <p:nvSpPr>
+          <p:cNvPr id="4" name="Slide Number Placeholder 3"/>
+          <p:cNvSpPr>
+            <a:spLocks noGrp="1"/>
+          </p:cNvSpPr>
+          <p:nvPr>
+            <p:ph type="sldNum" idx="5" sz="quarter"/>
+          </p:nvPr>
+        </p:nvSpPr>
+        <p:spPr/>
+      </p:sp>
+    </p:spTree>
+  </p:cSld>
+  <p:clrMapOvr>
+    <a:masterClrMapping/>
+  </p:clrMapOvr>
+</p:notes>
+</file>
+
+<file path=ppt/notesSlides/notesSlide12.xml><?xml version="1.0" encoding="utf-8"?>
+<p:notes xmlns:a="http://schemas.openxmlformats.org/drawingml/2006/main" xmlns:p="http://schemas.openxmlformats.org/presentationml/2006/main" xmlns:r="http://schemas.openxmlformats.org/officeDocument/2006/relationships">
+  <p:cSld>
+    <p:spTree>
+      <p:nvGrpSpPr>
+        <p:cNvPr id="1" name=""/>
+        <p:cNvGrpSpPr/>
+        <p:nvPr/>
+      </p:nvGrpSpPr>
+      <p:grpSpPr>
+        <a:xfrm>
+          <a:off x="0" y="0"/>
+          <a:ext cx="0" cy="0"/>
+          <a:chOff x="0" y="0"/>
+          <a:chExt cx="0" cy="0"/>
+        </a:xfrm>
+      </p:grpSpPr>
+      <p:sp>
+        <p:nvSpPr>
+          <p:cNvPr id="2" name="Slide Image Placeholder 1"/>
+          <p:cNvSpPr>
+            <a:spLocks noGrp="1"/>
+          </p:cNvSpPr>
+          <p:nvPr>
+            <p:ph type="sldImg" idx="2"/>
+          </p:nvPr>
+        </p:nvSpPr>
+        <p:spPr/>
+      </p:sp>
+      <p:sp>
+        <p:nvSpPr>
+          <p:cNvPr id="3" name="Notes Placeholder 2"/>
+          <p:cNvSpPr>
+            <a:spLocks noGrp="1"/>
+          </p:cNvSpPr>
+          <p:nvPr>
+            <p:ph type="body" idx="3" sz="quarter"/>
+          </p:nvPr>
+        </p:nvSpPr>
+        <p:spPr/>
+        <p:txBody>
+          <a:bodyPr/>
+          <a:lstStyle/>
+          <a:p>
+            <a:r>
+              <a:t>[12:15 · 1m00s] FINDING THREE. The recommendation, with its counter-case.</a:t>
+            </a:r>
+          </a:p>
+          <a:p/>
+          <a:p>
+            <a:r>
+              <a:t>Logistic regression for the shadow pilot. XGBoost as challenger, running in</a:t>
+            </a:r>
+          </a:p>
+          <a:p>
+            <a:r>
+              <a:t>parallel on the same cohort.</a:t>
+            </a:r>
+          </a:p>
+          <a:p/>
+          <a:p>
+            <a:r>
+              <a:t>Be explicit about what we give up: XGBoost is ahead on AUC and Brier. Those are</a:t>
+            </a:r>
+          </a:p>
+          <a:p>
+            <a:r>
+              <a:t>real, significant differences.</a:t>
+            </a:r>
+          </a:p>
+          <a:p/>
+          <a:p>
+            <a:r>
+              <a:t>They do not reach the decision. At the deployed rule the two models offer support</a:t>
+            </a:r>
+          </a:p>
+          <a:p>
+            <a:r>
+              <a:t>to 85% of the SAME people — 254 of 7,807 differ — and the difference in captured</a:t>
+            </a:r>
+          </a:p>
+          <a:p>
+            <a:r>
+              <a:t>re-arrests has an interval spanning zero.</a:t>
+            </a:r>
+          </a:p>
+          <a:p/>
+          <a:p>
+            <a:r>
+              <a:t>State what we do NOT claim, because a juror will test it: logistic is not fairer</a:t>
+            </a:r>
+          </a:p>
+          <a:p>
+            <a:r>
+              <a:t>and not better calibrated. On both, the two are statistically tied. We chose it</a:t>
+            </a:r>
+          </a:p>
+          <a:p>
+            <a:r>
+              <a:t>for refit stability and for coefficients you can read without a second tool.</a:t>
+            </a:r>
+          </a:p>
+          <a:p/>
+          <a:p>
+            <a:r>
+              <a:t>And what would reverse it: if the client quotes probabilities numerically to</a:t>
+            </a:r>
+          </a:p>
+          <a:p>
+            <a:r>
+              <a:t>supervisees, calibration starts to dominate. If their capacity is large enough that</a:t>
+            </a:r>
+          </a:p>
+          <a:p>
+            <a:r>
+              <a:t>twelve extra offers matters. That is why the challenger runs in parallel.</a:t>
+            </a:r>
+          </a:p>
+        </p:txBody>
+      </p:sp>
+      <p:sp>
+        <p:nvSpPr>
+          <p:cNvPr id="4" name="Slide Number Placeholder 3"/>
+          <p:cNvSpPr>
+            <a:spLocks noGrp="1"/>
+          </p:cNvSpPr>
+          <p:nvPr>
+            <p:ph type="sldNum" idx="5" sz="quarter"/>
+          </p:nvPr>
+        </p:nvSpPr>
+        <p:spPr/>
+      </p:sp>
+    </p:spTree>
+  </p:cSld>
+  <p:clrMapOvr>
+    <a:masterClrMapping/>
+  </p:clrMapOvr>
+</p:notes>
+</file>
+
+<file path=ppt/notesSlides/notesSlide13.xml><?xml version="1.0" encoding="utf-8"?>
+<p:notes xmlns:a="http://schemas.openxmlformats.org/drawingml/2006/main" xmlns:p="http://schemas.openxmlformats.org/presentationml/2006/main" xmlns:r="http://schemas.openxmlformats.org/officeDocument/2006/relationships">
+  <p:cSld>
+    <p:spTree>
+      <p:nvGrpSpPr>
+        <p:cNvPr id="1" name=""/>
+        <p:cNvGrpSpPr/>
+        <p:nvPr/>
+      </p:nvGrpSpPr>
+      <p:grpSpPr>
+        <a:xfrm>
+          <a:off x="0" y="0"/>
+          <a:ext cx="0" cy="0"/>
+          <a:chOff x="0" y="0"/>
+          <a:chExt cx="0" cy="0"/>
+        </a:xfrm>
+      </p:grpSpPr>
+      <p:sp>
+        <p:nvSpPr>
+          <p:cNvPr id="2" name="Slide Image Placeholder 1"/>
+          <p:cNvSpPr>
+            <a:spLocks noGrp="1"/>
+          </p:cNvSpPr>
+          <p:nvPr>
+            <p:ph type="sldImg" idx="2"/>
+          </p:nvPr>
+        </p:nvSpPr>
+        <p:spPr/>
+      </p:sp>
+      <p:sp>
+        <p:nvSpPr>
+          <p:cNvPr id="3" name="Notes Placeholder 2"/>
+          <p:cNvSpPr>
+            <a:spLocks noGrp="1"/>
+          </p:cNvSpPr>
+          <p:nvPr>
+            <p:ph type="body" idx="3" sz="quarter"/>
+          </p:nvPr>
+        </p:nvSpPr>
+        <p:spPr/>
+        <p:txBody>
+          <a:bodyPr/>
+          <a:lstStyle/>
+          <a:p>
+            <a:r>
+              <a:t>[13:15 · 45s] The app, and close.</a:t>
+            </a:r>
+          </a:p>
+          <a:p/>
+          <a:p>
+            <a:r>
+              <a:t>The application makes every trade-off testable: score one person with all three</a:t>
+            </a:r>
+          </a:p>
+          <a:p>
+            <a:r>
+              <a:t>models, see the explanation, audit by race, gender and age at the deployed point,</a:t>
+            </a:r>
+          </a:p>
+          <a:p>
+            <a:r>
+              <a:t>and edit the cost assumptions.</a:t>
+            </a:r>
+          </a:p>
+          <a:p/>
+          <a:p>
+            <a:r>
+              <a:t>One thing to demo if there is time: pick a person and show the refit vote count.</a:t>
+            </a:r>
+          </a:p>
+          <a:p>
+            <a:r>
+              <a:t>About one decision in seven flips across refits, and a third of the people we</a:t>
+            </a:r>
+          </a:p>
+          <a:p>
+            <a:r>
+              <a:t>prioritise sit at that margin. The app shows that rather than hiding it behind a</a:t>
+            </a:r>
+          </a:p>
+          <a:p>
+            <a:r>
+              <a:t>point estimate.</a:t>
+            </a:r>
+          </a:p>
+          <a:p/>
+          <a:p>
+            <a:r>
+              <a:t>Close on the frame: we are not trading accuracy for interpretability. The accuracy</a:t>
+            </a:r>
+          </a:p>
+          <a:p>
+            <a:r>
+              <a:t>difference does not change who gets help.</a:t>
+            </a:r>
+          </a:p>
+          <a:p/>
+          <a:p>
+            <a:r>
+              <a:t>[APPENDIX CUES — jump to these on the matching question]</a:t>
+            </a:r>
+          </a:p>
+          <a:p>
+            <a:r>
+              <a:t>A1 learning curve · A2 economics and sensitivity · A3 interpretability methods</a:t>
+            </a:r>
+          </a:p>
+          <a:p>
+            <a:r>
+              <a:t>A4 why SHAP, permutation importance and XPER disagree · A5 LIME fidelity</a:t>
+            </a:r>
+          </a:p>
+          <a:p>
+            <a:r>
+              <a:t>A6 stability detail · A7 what we tried and rejected · A8 proxy recovery</a:t>
+            </a:r>
+          </a:p>
+          <a:p>
+            <a:r>
+              <a:t>A9 per-person stability and the abstention finding</a:t>
+            </a:r>
+          </a:p>
+        </p:txBody>
+      </p:sp>
+      <p:sp>
+        <p:nvSpPr>
+          <p:cNvPr id="4" name="Slide Number Placeholder 3"/>
+          <p:cNvSpPr>
+            <a:spLocks noGrp="1"/>
+          </p:cNvSpPr>
+          <p:nvPr>
+            <p:ph type="sldNum" idx="5" sz="quarter"/>
+          </p:nvPr>
+        </p:nvSpPr>
+        <p:spPr/>
+      </p:sp>
+    </p:spTree>
+  </p:cSld>
+  <p:clrMapOvr>
+    <a:masterClrMapping/>
+  </p:clrMapOvr>
+</p:notes>
+</file>
+
+<file path=ppt/notesSlides/notesSlide2.xml><?xml version="1.0" encoding="utf-8"?>
+<p:notes xmlns:a="http://schemas.openxmlformats.org/drawingml/2006/main" xmlns:p="http://schemas.openxmlformats.org/presentationml/2006/main" xmlns:r="http://schemas.openxmlformats.org/officeDocument/2006/relationships">
+  <p:cSld>
+    <p:spTree>
+      <p:nvGrpSpPr>
+        <p:cNvPr id="1" name=""/>
+        <p:cNvGrpSpPr/>
+        <p:nvPr/>
+      </p:nvGrpSpPr>
+      <p:grpSpPr>
+        <a:xfrm>
+          <a:off x="0" y="0"/>
+          <a:ext cx="0" cy="0"/>
+          <a:chOff x="0" y="0"/>
+          <a:chExt cx="0" cy="0"/>
+        </a:xfrm>
+      </p:grpSpPr>
+      <p:sp>
+        <p:nvSpPr>
+          <p:cNvPr id="2" name="Slide Image Placeholder 1"/>
+          <p:cNvSpPr>
+            <a:spLocks noGrp="1"/>
+          </p:cNvSpPr>
+          <p:nvPr>
+            <p:ph type="sldImg" idx="2"/>
+          </p:nvPr>
+        </p:nvSpPr>
+        <p:spPr/>
+      </p:sp>
+      <p:sp>
+        <p:nvSpPr>
+          <p:cNvPr id="3" name="Notes Placeholder 2"/>
+          <p:cNvSpPr>
+            <a:spLocks noGrp="1"/>
+          </p:cNvSpPr>
+          <p:nvPr>
+            <p:ph type="body" idx="3" sz="quarter"/>
+          </p:nvPr>
+        </p:nvSpPr>
+        <p:spPr/>
+        <p:txBody>
+          <a:bodyPr/>
+          <a:lstStyle/>
+          <a:p>
+            <a:r>
+              <a:t>[0:30 · 45s] The decision being sold.</a:t>
+            </a:r>
+          </a:p>
+          <a:p/>
+          <a:p>
+            <a:r>
+              <a:t>The score prioritises VOLUNTARY re-entry support at the start of parole:</a:t>
+            </a:r>
+          </a:p>
+          <a:p>
+            <a:r>
+              <a:t>employment, housing, treatment. Never sanctions, never detention, never</a:t>
+            </a:r>
+          </a:p>
+          <a:p>
+            <a:r>
+              <a:t>surveillance.</a:t>
+            </a:r>
+          </a:p>
+          <a:p/>
+          <a:p>
+            <a:r>
+              <a:t>Land the ethical scoping here, because everything later depends on it. Our model</a:t>
+            </a:r>
+          </a:p>
+          <a:p>
+            <a:r>
+              <a:t>is wrong often — at the top 20%, about one in six people offered support are not</a:t>
+            </a:r>
+          </a:p>
+          <a:p>
+            <a:r>
+              <a:t>re-arrested. For OFFERING HELP that is an acceptable cost. For punishment it</a:t>
+            </a:r>
+          </a:p>
+          <a:p>
+            <a:r>
+              <a:t>would not be. If a juror later challenges the error rate, this is the answer.</a:t>
+            </a:r>
+          </a:p>
+        </p:txBody>
+      </p:sp>
+      <p:sp>
+        <p:nvSpPr>
+          <p:cNvPr id="4" name="Slide Number Placeholder 3"/>
+          <p:cNvSpPr>
+            <a:spLocks noGrp="1"/>
+          </p:cNvSpPr>
+          <p:nvPr>
+            <p:ph type="sldNum" idx="5" sz="quarter"/>
+          </p:nvPr>
+        </p:nvSpPr>
+        <p:spPr/>
+      </p:sp>
+    </p:spTree>
+  </p:cSld>
+  <p:clrMapOvr>
+    <a:masterClrMapping/>
+  </p:clrMapOvr>
+</p:notes>
+</file>
+
+<file path=ppt/notesSlides/notesSlide3.xml><?xml version="1.0" encoding="utf-8"?>
+<p:notes xmlns:a="http://schemas.openxmlformats.org/drawingml/2006/main" xmlns:p="http://schemas.openxmlformats.org/presentationml/2006/main" xmlns:r="http://schemas.openxmlformats.org/officeDocument/2006/relationships">
+  <p:cSld>
+    <p:spTree>
+      <p:nvGrpSpPr>
+        <p:cNvPr id="1" name=""/>
+        <p:cNvGrpSpPr/>
+        <p:nvPr/>
+      </p:nvGrpSpPr>
+      <p:grpSpPr>
+        <a:xfrm>
+          <a:off x="0" y="0"/>
+          <a:ext cx="0" cy="0"/>
+          <a:chOff x="0" y="0"/>
+          <a:chExt cx="0" cy="0"/>
+        </a:xfrm>
+      </p:grpSpPr>
+      <p:sp>
+        <p:nvSpPr>
+          <p:cNvPr id="2" name="Slide Image Placeholder 1"/>
+          <p:cNvSpPr>
+            <a:spLocks noGrp="1"/>
+          </p:cNvSpPr>
+          <p:nvPr>
+            <p:ph type="sldImg" idx="2"/>
+          </p:nvPr>
+        </p:nvSpPr>
+        <p:spPr/>
+      </p:sp>
+      <p:sp>
+        <p:nvSpPr>
+          <p:cNvPr id="3" name="Notes Placeholder 2"/>
+          <p:cNvSpPr>
+            <a:spLocks noGrp="1"/>
+          </p:cNvSpPr>
+          <p:nvPr>
+            <p:ph type="body" idx="3" sz="quarter"/>
+          </p:nvPr>
+        </p:nvSpPr>
+        <p:spPr/>
+        <p:txBody>
+          <a:bodyPr/>
+          <a:lstStyle/>
+          <a:p>
+            <a:r>
+              <a:t>[1:15 · 1m30s] Data design, and the leak.</a:t>
+            </a:r>
+          </a:p>
+          <a:p/>
+          <a:p>
+            <a:r>
+              <a:t>NIJ's own split — we did not make a new one. 18,028 train, 7,807 evaluation,</a:t>
+            </a:r>
+          </a:p>
+          <a:p>
+            <a:r>
+              <a:t>29 fields available at supervision start.</a:t>
+            </a:r>
+          </a:p>
+          <a:p/>
+          <a:p>
+            <a:r>
+              <a:t>Two things to say plainly rather than bury:</a:t>
+            </a:r>
+          </a:p>
+          <a:p/>
+          <a:p>
+            <a:r>
+              <a:t>First, the evaluation set is NOT an untouched holdout. It is excluded from</a:t>
+            </a:r>
+          </a:p>
+          <a:p>
+            <a:r>
+              <a:t>fitting, but our development decisions inspected it. Our comparisons are</a:t>
+            </a:r>
+          </a:p>
+          <a:p>
+            <a:r>
+              <a:t>exploratory. Say it before anyone asks.</a:t>
+            </a:r>
+          </a:p>
+          <a:p/>
+          <a:p>
+            <a:r>
+              <a:t>Second, the leak — this is our strongest slide. Gang affiliation is missing for</a:t>
+            </a:r>
+          </a:p>
+          <a:p>
+            <a:r>
+              <a:t>every woman and no man. The missingness pattern IS gender. TabICL encodes NaN as</a:t>
+            </a:r>
+          </a:p>
+          <a:p>
+            <a:r>
+              <a:t>a category, so it could read the attribute we thought we had excluded. We measured</a:t>
+            </a:r>
+          </a:p>
+          <a:p>
+            <a:r>
+              <a:t>the cost: with missingness indicators, gender is recoverable at AUC 1.00.</a:t>
+            </a:r>
+          </a:p>
+          <a:p>
+            <a:r>
+              <a:t>Perfectly. We fixed it with mode-filling and a regression test.</a:t>
+            </a:r>
+          </a:p>
+        </p:txBody>
+      </p:sp>
+      <p:sp>
+        <p:nvSpPr>
+          <p:cNvPr id="4" name="Slide Number Placeholder 3"/>
+          <p:cNvSpPr>
+            <a:spLocks noGrp="1"/>
+          </p:cNvSpPr>
+          <p:nvPr>
+            <p:ph type="sldNum" idx="5" sz="quarter"/>
+          </p:nvPr>
+        </p:nvSpPr>
+        <p:spPr/>
+      </p:sp>
+    </p:spTree>
+  </p:cSld>
+  <p:clrMapOvr>
+    <a:masterClrMapping/>
+  </p:clrMapOvr>
+</p:notes>
+</file>
+
+<file path=ppt/notesSlides/notesSlide4.xml><?xml version="1.0" encoding="utf-8"?>
+<p:notes xmlns:a="http://schemas.openxmlformats.org/drawingml/2006/main" xmlns:p="http://schemas.openxmlformats.org/presentationml/2006/main" xmlns:r="http://schemas.openxmlformats.org/officeDocument/2006/relationships">
+  <p:cSld>
+    <p:spTree>
+      <p:nvGrpSpPr>
+        <p:cNvPr id="1" name=""/>
+        <p:cNvGrpSpPr/>
+        <p:nvPr/>
+      </p:nvGrpSpPr>
+      <p:grpSpPr>
+        <a:xfrm>
+          <a:off x="0" y="0"/>
+          <a:ext cx="0" cy="0"/>
+          <a:chOff x="0" y="0"/>
+          <a:chExt cx="0" cy="0"/>
+        </a:xfrm>
+      </p:grpSpPr>
+      <p:sp>
+        <p:nvSpPr>
+          <p:cNvPr id="2" name="Slide Image Placeholder 1"/>
+          <p:cNvSpPr>
+            <a:spLocks noGrp="1"/>
+          </p:cNvSpPr>
+          <p:nvPr>
+            <p:ph type="sldImg" idx="2"/>
+          </p:nvPr>
+        </p:nvSpPr>
+        <p:spPr/>
+      </p:sp>
+      <p:sp>
+        <p:nvSpPr>
+          <p:cNvPr id="3" name="Notes Placeholder 2"/>
+          <p:cNvSpPr>
+            <a:spLocks noGrp="1"/>
+          </p:cNvSpPr>
+          <p:nvPr>
+            <p:ph type="body" idx="3" sz="quarter"/>
+          </p:nvPr>
+        </p:nvSpPr>
+        <p:spPr/>
+        <p:txBody>
+          <a:bodyPr/>
+          <a:lstStyle/>
+          <a:p>
+            <a:r>
+              <a:t>[2:45 · 1m00s] Three model families.</a:t>
+            </a:r>
+          </a:p>
+          <a:p/>
+          <a:p>
+            <a:r>
+              <a:t>White-box, machine learning, foundation model — as the brief requires. Same 29</a:t>
+            </a:r>
+          </a:p>
+          <a:p>
+            <a:r>
+              <a:t>fields, same held-out people, same metrics.</a:t>
+            </a:r>
+          </a:p>
+          <a:p/>
+          <a:p>
+            <a:r>
+              <a:t>Logistic is CV-tuned L1. XGBoost ordinal-encodes ordered counts, hyperparameters</a:t>
+            </a:r>
+          </a:p>
+          <a:p>
+            <a:r>
+              <a:t>from a 5-fold CV random search that is committed as code, not asserted. TabICL is</a:t>
+            </a:r>
+          </a:p>
+          <a:p>
+            <a:r>
+              <a:t>a 16-member GPU ensemble.</a:t>
+            </a:r>
+          </a:p>
+          <a:p/>
+          <a:p>
+            <a:r>
+              <a:t>Flag the one that matters for later: TabICL has NO native attribution path. That</a:t>
+            </a:r>
+          </a:p>
+          <a:p>
+            <a:r>
+              <a:t>is a deployment cost, and it comes back on the recommendation slide.</a:t>
+            </a:r>
+          </a:p>
+        </p:txBody>
+      </p:sp>
+      <p:sp>
+        <p:nvSpPr>
+          <p:cNvPr id="4" name="Slide Number Placeholder 3"/>
+          <p:cNvSpPr>
+            <a:spLocks noGrp="1"/>
+          </p:cNvSpPr>
+          <p:nvPr>
+            <p:ph type="sldNum" idx="5" sz="quarter"/>
+          </p:nvPr>
+        </p:nvSpPr>
+        <p:spPr/>
+      </p:sp>
+    </p:spTree>
+  </p:cSld>
+  <p:clrMapOvr>
+    <a:masterClrMapping/>
+  </p:clrMapOvr>
+</p:notes>
+</file>
+
+<file path=ppt/notesSlides/notesSlide5.xml><?xml version="1.0" encoding="utf-8"?>
+<p:notes xmlns:a="http://schemas.openxmlformats.org/drawingml/2006/main" xmlns:p="http://schemas.openxmlformats.org/presentationml/2006/main" xmlns:r="http://schemas.openxmlformats.org/officeDocument/2006/relationships">
+  <p:cSld>
+    <p:spTree>
+      <p:nvGrpSpPr>
+        <p:cNvPr id="1" name=""/>
+        <p:cNvGrpSpPr/>
+        <p:nvPr/>
+      </p:nvGrpSpPr>
+      <p:grpSpPr>
+        <a:xfrm>
+          <a:off x="0" y="0"/>
+          <a:ext cx="0" cy="0"/>
+          <a:chOff x="0" y="0"/>
+          <a:chExt cx="0" cy="0"/>
+        </a:xfrm>
+      </p:grpSpPr>
+      <p:sp>
+        <p:nvSpPr>
+          <p:cNvPr id="2" name="Slide Image Placeholder 1"/>
+          <p:cNvSpPr>
+            <a:spLocks noGrp="1"/>
+          </p:cNvSpPr>
+          <p:nvPr>
+            <p:ph type="sldImg" idx="2"/>
+          </p:nvPr>
+        </p:nvSpPr>
+        <p:spPr/>
+      </p:sp>
+      <p:sp>
+        <p:nvSpPr>
+          <p:cNvPr id="3" name="Notes Placeholder 2"/>
+          <p:cNvSpPr>
+            <a:spLocks noGrp="1"/>
+          </p:cNvSpPr>
+          <p:nvPr>
+            <p:ph type="body" idx="3" sz="quarter"/>
+          </p:nvPr>
+        </p:nvSpPr>
+        <p:spPr/>
+        <p:txBody>
+          <a:bodyPr/>
+          <a:lstStyle/>
+          <a:p>
+            <a:r>
+              <a:t>[3:45 · 1m00s] The client's real question.</a:t>
+            </a:r>
+          </a:p>
+          <a:p/>
+          <a:p>
+            <a:r>
+              <a:t>Not "which of your three models" — that is our question. Theirs is: is any of this</a:t>
+            </a:r>
+          </a:p>
+          <a:p>
+            <a:r>
+              <a:t>better than what we already run?</a:t>
+            </a:r>
+          </a:p>
+          <a:p/>
+          <a:p>
+            <a:r>
+              <a:t>This dataset contains Georgia's recorded supervision score, which we use as one</a:t>
+            </a:r>
+          </a:p>
+          <a:p>
+            <a:r>
+              <a:t>input. On its own it reaches 0.60 AUC. Our models reach 0.73. At 20% capacity that</a:t>
+            </a:r>
+          </a:p>
+          <a:p>
+            <a:r>
+              <a:t>roughly doubles the net value of the scenario.</a:t>
+            </a:r>
+          </a:p>
+          <a:p/>
+          <a:p>
+            <a:r>
+              <a:t>Give the caveat in the same breath: this is a HISTORICAL recorded score. It does</a:t>
+            </a:r>
+          </a:p>
+          <a:p>
+            <a:r>
+              <a:t>not tell us how today's commercial products perform. And the dollars are a</a:t>
+            </a:r>
+          </a:p>
+          <a:p>
+            <a:r>
+              <a:t>scenario — effectiveness is assumed, not measured.</a:t>
+            </a:r>
+          </a:p>
+        </p:txBody>
+      </p:sp>
+      <p:sp>
+        <p:nvSpPr>
+          <p:cNvPr id="4" name="Slide Number Placeholder 3"/>
+          <p:cNvSpPr>
+            <a:spLocks noGrp="1"/>
+          </p:cNvSpPr>
+          <p:nvPr>
+            <p:ph type="sldNum" idx="5" sz="quarter"/>
+          </p:nvPr>
+        </p:nvSpPr>
+        <p:spPr/>
+      </p:sp>
+    </p:spTree>
+  </p:cSld>
+  <p:clrMapOvr>
+    <a:masterClrMapping/>
+  </p:clrMapOvr>
+</p:notes>
+</file>
+
+<file path=ppt/notesSlides/notesSlide6.xml><?xml version="1.0" encoding="utf-8"?>
+<p:notes xmlns:a="http://schemas.openxmlformats.org/drawingml/2006/main" xmlns:p="http://schemas.openxmlformats.org/presentationml/2006/main" xmlns:r="http://schemas.openxmlformats.org/officeDocument/2006/relationships">
+  <p:cSld>
+    <p:spTree>
+      <p:nvGrpSpPr>
+        <p:cNvPr id="1" name=""/>
+        <p:cNvGrpSpPr/>
+        <p:nvPr/>
+      </p:nvGrpSpPr>
+      <p:grpSpPr>
+        <a:xfrm>
+          <a:off x="0" y="0"/>
+          <a:ext cx="0" cy="0"/>
+          <a:chOff x="0" y="0"/>
+          <a:chExt cx="0" cy="0"/>
+        </a:xfrm>
+      </p:grpSpPr>
+      <p:sp>
+        <p:nvSpPr>
+          <p:cNvPr id="2" name="Slide Image Placeholder 1"/>
+          <p:cNvSpPr>
+            <a:spLocks noGrp="1"/>
+          </p:cNvSpPr>
+          <p:nvPr>
+            <p:ph type="sldImg" idx="2"/>
+          </p:nvPr>
+        </p:nvSpPr>
+        <p:spPr/>
+      </p:sp>
+      <p:sp>
+        <p:nvSpPr>
+          <p:cNvPr id="3" name="Notes Placeholder 2"/>
+          <p:cNvSpPr>
+            <a:spLocks noGrp="1"/>
+          </p:cNvSpPr>
+          <p:nvPr>
+            <p:ph type="body" idx="3" sz="quarter"/>
+          </p:nvPr>
+        </p:nvSpPr>
+        <p:spPr/>
+        <p:txBody>
+          <a:bodyPr/>
+          <a:lstStyle/>
+          <a:p>
+            <a:r>
+              <a:t>[4:45 · 1m30s] FINDING ONE. Performance cannot pick the model.</a:t>
+            </a:r>
+          </a:p>
+          <a:p/>
+          <a:p>
+            <a:r>
+              <a:t>All three are within 0.003 AUC. XGBoost beats logistic by +0.0025 with a paired</a:t>
+            </a:r>
+          </a:p>
+          <a:p>
+            <a:r>
+              <a:t>interval excluding zero — real, but tiny.</a:t>
+            </a:r>
+          </a:p>
+          <a:p/>
+          <a:p>
+            <a:r>
+              <a:t>Two methodological points worth making, because they show the work:</a:t>
+            </a:r>
+          </a:p>
+          <a:p/>
+          <a:p>
+            <a:r>
+              <a:t>We use PAIRED bootstrap differences. Comparing two separate intervals for overlap</a:t>
+            </a:r>
+          </a:p>
+          <a:p>
+            <a:r>
+              <a:t>is weaker and commonly misread.</a:t>
+            </a:r>
+          </a:p>
+          <a:p/>
+          <a:p>
+            <a:r>
+              <a:t>ECE differences are not significant, and the ECE ranking is not even stable across</a:t>
+            </a:r>
+          </a:p>
+          <a:p>
+            <a:r>
+              <a:t>binning choices. We tested calibration bin-free instead: logistic and XGBoost are</a:t>
+            </a:r>
+          </a:p>
+          <a:p>
+            <a:r>
+              <a:t>both indistinguishable from perfect calibration. TabICL is the exception — slope</a:t>
+            </a:r>
+          </a:p>
+          <a:p>
+            <a:r>
+              <a:t>0.913, significantly below 1. Its probabilities are too extreme.</a:t>
+            </a:r>
+          </a:p>
+          <a:p/>
+          <a:p>
+            <a:r>
+              <a:t>So: performance does not discriminate. Interpretability, stability and fairness do.</a:t>
+            </a:r>
+          </a:p>
+        </p:txBody>
+      </p:sp>
+      <p:sp>
+        <p:nvSpPr>
+          <p:cNvPr id="4" name="Slide Number Placeholder 3"/>
+          <p:cNvSpPr>
+            <a:spLocks noGrp="1"/>
+          </p:cNvSpPr>
+          <p:nvPr>
+            <p:ph type="sldNum" idx="5" sz="quarter"/>
+          </p:nvPr>
+        </p:nvSpPr>
+        <p:spPr/>
+      </p:sp>
+    </p:spTree>
+  </p:cSld>
+  <p:clrMapOvr>
+    <a:masterClrMapping/>
+  </p:clrMapOvr>
+</p:notes>
+</file>
+
+<file path=ppt/notesSlides/notesSlide7.xml><?xml version="1.0" encoding="utf-8"?>
+<p:notes xmlns:a="http://schemas.openxmlformats.org/drawingml/2006/main" xmlns:p="http://schemas.openxmlformats.org/presentationml/2006/main" xmlns:r="http://schemas.openxmlformats.org/officeDocument/2006/relationships">
+  <p:cSld>
+    <p:spTree>
+      <p:nvGrpSpPr>
+        <p:cNvPr id="1" name=""/>
+        <p:cNvGrpSpPr/>
+        <p:nvPr/>
+      </p:nvGrpSpPr>
+      <p:grpSpPr>
+        <a:xfrm>
+          <a:off x="0" y="0"/>
+          <a:ext cx="0" cy="0"/>
+          <a:chOff x="0" y="0"/>
+          <a:chExt cx="0" cy="0"/>
+        </a:xfrm>
+      </p:grpSpPr>
+      <p:sp>
+        <p:nvSpPr>
+          <p:cNvPr id="2" name="Slide Image Placeholder 1"/>
+          <p:cNvSpPr>
+            <a:spLocks noGrp="1"/>
+          </p:cNvSpPr>
+          <p:nvPr>
+            <p:ph type="sldImg" idx="2"/>
+          </p:nvPr>
+        </p:nvSpPr>
+        <p:spPr/>
+      </p:sp>
+      <p:sp>
+        <p:nvSpPr>
+          <p:cNvPr id="3" name="Notes Placeholder 2"/>
+          <p:cNvSpPr>
+            <a:spLocks noGrp="1"/>
+          </p:cNvSpPr>
+          <p:nvPr>
+            <p:ph type="body" idx="3" sz="quarter"/>
+          </p:nvPr>
+        </p:nvSpPr>
+        <p:spPr/>
+        <p:txBody>
+          <a:bodyPr/>
+          <a:lstStyle/>
+          <a:p>
+            <a:r>
+              <a:t>[6:15 · 2m00s] FINDING TWO. Unequal access to support.</a:t>
+            </a:r>
+          </a:p>
+          <a:p/>
+          <a:p>
+            <a:r>
+              <a:t>Slow down here. This is the centre of the talk.</a:t>
+            </a:r>
+          </a:p>
+          <a:p/>
+          <a:p>
+            <a:r>
+              <a:t>First the framing: selection means being OFFERED support. So the harm is a missed</a:t>
+            </a:r>
+          </a:p>
+          <a:p>
+            <a:r>
+              <a:t>offer, and FNR — equal opportunity — is our primary metric, not FPR.</a:t>
+            </a:r>
+          </a:p>
+          <a:p/>
+          <a:p>
+            <a:r>
+              <a:t>Second, the operating point. We audit at the top-20% rule the product actually</a:t>
+            </a:r>
+          </a:p>
+          <a:p>
+            <a:r>
+              <a:t>ships, not at threshold 0.5. At 0.5 the tool would flag 68% of people. That is not</a:t>
+            </a:r>
+          </a:p>
+          <a:p>
+            <a:r>
+              <a:t>a threshold this product ever applies, and auditing there inflates every gap.</a:t>
+            </a:r>
+          </a:p>
+          <a:p/>
+          <a:p>
+            <a:r>
+              <a:t>The results:</a:t>
+            </a:r>
+          </a:p>
+          <a:p>
+            <a:r>
+              <a:t>— Race: equivalent within ±5 points for all three models by TOST. No race test</a:t>
+            </a:r>
+          </a:p>
+          <a:p>
+            <a:r>
+              <a:t>  survives Holm correction across our 54 tests. Small, and unconfirmed.</a:t>
+            </a:r>
+          </a:p>
+          <a:p>
+            <a:r>
+              <a:t>— Gender: women who ARE re-arrested miss support 10 to 12 points more often.</a:t>
+            </a:r>
+          </a:p>
+          <a:p>
+            <a:r>
+              <a:t>  Significant for every model.</a:t>
+            </a:r>
+          </a:p>
+          <a:p>
+            <a:r>
+              <a:t>— Age: the largest disparity, 23 to 25 points. About 97% of re-arrested people</a:t>
+            </a:r>
+          </a:p>
+          <a:p>
+            <a:r>
+              <a:t>  aged 48+ are never selected. It persists even with the age field held fixed,</a:t>
+            </a:r>
+          </a:p>
+          <a:p>
+            <a:r>
+              <a:t>  because prior record carries age.</a:t>
+            </a:r>
+          </a:p>
+          <a:p/>
+          <a:p>
+            <a:r>
+              <a:t>Say the honest line: not significant does NOT mean fair. That is why we test</a:t>
+            </a:r>
+          </a:p>
+          <a:p>
+            <a:r>
+              <a:t>equivalence, not just difference.</a:t>
+            </a:r>
+          </a:p>
+        </p:txBody>
+      </p:sp>
+      <p:sp>
+        <p:nvSpPr>
+          <p:cNvPr id="4" name="Slide Number Placeholder 3"/>
+          <p:cNvSpPr>
+            <a:spLocks noGrp="1"/>
+          </p:cNvSpPr>
+          <p:nvPr>
+            <p:ph type="sldNum" idx="5" sz="quarter"/>
+          </p:nvPr>
+        </p:nvSpPr>
+        <p:spPr/>
+      </p:sp>
+    </p:spTree>
+  </p:cSld>
+  <p:clrMapOvr>
+    <a:masterClrMapping/>
+  </p:clrMapOvr>
+</p:notes>
+</file>
+
+<file path=ppt/notesSlides/notesSlide8.xml><?xml version="1.0" encoding="utf-8"?>
+<p:notes xmlns:a="http://schemas.openxmlformats.org/drawingml/2006/main" xmlns:p="http://schemas.openxmlformats.org/presentationml/2006/main" xmlns:r="http://schemas.openxmlformats.org/officeDocument/2006/relationships">
+  <p:cSld>
+    <p:spTree>
+      <p:nvGrpSpPr>
+        <p:cNvPr id="1" name=""/>
+        <p:cNvGrpSpPr/>
+        <p:nvPr/>
+      </p:nvGrpSpPr>
+      <p:grpSpPr>
+        <a:xfrm>
+          <a:off x="0" y="0"/>
+          <a:ext cx="0" cy="0"/>
+          <a:chOff x="0" y="0"/>
+          <a:chExt cx="0" cy="0"/>
+        </a:xfrm>
+      </p:grpSpPr>
+      <p:sp>
+        <p:nvSpPr>
+          <p:cNvPr id="2" name="Slide Image Placeholder 1"/>
+          <p:cNvSpPr>
+            <a:spLocks noGrp="1"/>
+          </p:cNvSpPr>
+          <p:nvPr>
+            <p:ph type="sldImg" idx="2"/>
+          </p:nvPr>
+        </p:nvSpPr>
+        <p:spPr/>
+      </p:sp>
+      <p:sp>
+        <p:nvSpPr>
+          <p:cNvPr id="3" name="Notes Placeholder 2"/>
+          <p:cNvSpPr>
+            <a:spLocks noGrp="1"/>
+          </p:cNvSpPr>
+          <p:nvPr>
+            <p:ph type="body" idx="3" sz="quarter"/>
+          </p:nvPr>
+        </p:nvSpPr>
+        <p:spPr/>
+        <p:txBody>
+          <a:bodyPr/>
+          <a:lstStyle/>
+          <a:p>
+            <a:r>
+              <a:t>[8:15 · 1m00s] The impossibility result, both sides.</a:t>
+            </a:r>
+          </a:p>
+          <a:p/>
+          <a:p>
+            <a:r>
+              <a:t>Our data demonstrates both halves of the theorem within one project.</a:t>
+            </a:r>
+          </a:p>
+          <a:p/>
+          <a:p>
+            <a:r>
+              <a:t>Race: base rates 0.582 and 0.564 — nearly equal. The theorem does not bind, so</a:t>
+            </a:r>
+          </a:p>
+          <a:p>
+            <a:r>
+              <a:t>those gaps are a property of our models and are fixable.</a:t>
+            </a:r>
+          </a:p>
+          <a:p/>
+          <a:p>
+            <a:r>
+              <a:t>Gender: 0.591 against 0.454, fourteen points apart. Calibration and equal error</a:t>
+            </a:r>
+          </a:p>
+          <a:p>
+            <a:r>
+              <a:t>rates CANNOT both hold. We have to choose.</a:t>
+            </a:r>
+          </a:p>
+          <a:p/>
+          <a:p>
+            <a:r>
+              <a:t>The mechanism is visible in our numbers: every model over-predicts women — mean</a:t>
+            </a:r>
+          </a:p>
+          <a:p>
+            <a:r>
+              <a:t>score 0.52 against an observed 0.454 — yet women are selected less at the top 20%.</a:t>
+            </a:r>
+          </a:p>
+          <a:p/>
+          <a:p>
+            <a:r>
+              <a:t>And for THIS use, the direction matters. In a support programme over-prediction</a:t>
+            </a:r>
+          </a:p>
+          <a:p>
+            <a:r>
+              <a:t>works in women's favour. Recalibrating by gender would select even fewer women and</a:t>
+            </a:r>
+          </a:p>
+          <a:p>
+            <a:r>
+              <a:t>widen the gap. The harm here is the missed offer, not the miscalibration.</a:t>
+            </a:r>
+          </a:p>
+        </p:txBody>
+      </p:sp>
+      <p:sp>
+        <p:nvSpPr>
+          <p:cNvPr id="4" name="Slide Number Placeholder 3"/>
+          <p:cNvSpPr>
+            <a:spLocks noGrp="1"/>
+          </p:cNvSpPr>
+          <p:nvPr>
+            <p:ph type="sldNum" idx="5" sz="quarter"/>
+          </p:nvPr>
+        </p:nvSpPr>
+        <p:spPr/>
+      </p:sp>
+    </p:spTree>
+  </p:cSld>
+  <p:clrMapOvr>
+    <a:masterClrMapping/>
+  </p:clrMapOvr>
+</p:notes>
+</file>
+
+<file path=ppt/notesSlides/notesSlide9.xml><?xml version="1.0" encoding="utf-8"?>
+<p:notes xmlns:a="http://schemas.openxmlformats.org/drawingml/2006/main" xmlns:p="http://schemas.openxmlformats.org/presentationml/2006/main" xmlns:r="http://schemas.openxmlformats.org/officeDocument/2006/relationships">
+  <p:cSld>
+    <p:spTree>
+      <p:nvGrpSpPr>
+        <p:cNvPr id="1" name=""/>
+        <p:cNvGrpSpPr/>
+        <p:nvPr/>
+      </p:nvGrpSpPr>
+      <p:grpSpPr>
+        <a:xfrm>
+          <a:off x="0" y="0"/>
+          <a:ext cx="0" cy="0"/>
+          <a:chOff x="0" y="0"/>
+          <a:chExt cx="0" cy="0"/>
+        </a:xfrm>
+      </p:grpSpPr>
+      <p:sp>
+        <p:nvSpPr>
+          <p:cNvPr id="2" name="Slide Image Placeholder 1"/>
+          <p:cNvSpPr>
+            <a:spLocks noGrp="1"/>
+          </p:cNvSpPr>
+          <p:nvPr>
+            <p:ph type="sldImg" idx="2"/>
+          </p:nvPr>
+        </p:nvSpPr>
+        <p:spPr/>
+      </p:sp>
+      <p:sp>
+        <p:nvSpPr>
+          <p:cNvPr id="3" name="Notes Placeholder 2"/>
+          <p:cNvSpPr>
+            <a:spLocks noGrp="1"/>
+          </p:cNvSpPr>
+          <p:nvPr>
+            <p:ph type="body" idx="3" sz="quarter"/>
+          </p:nvPr>
+        </p:nvSpPr>
+        <p:spPr/>
+        <p:txBody>
+          <a:bodyPr/>
+          <a:lstStyle/>
+          <a:p>
+            <a:r>
+              <a:t>[9:15 · 1m00s] Where the gender gap comes from.</a:t>
+            </a:r>
+          </a:p>
+          <a:p/>
+          <a:p>
+            <a:r>
+              <a:t>We did not stop at measuring. The course sequence is test, identify the variable,</a:t>
+            </a:r>
+          </a:p>
+          <a:p>
+            <a:r>
+              <a:t>mitigate — and fairness partial dependence names the candidate.</a:t>
+            </a:r>
+          </a:p>
+          <a:p/>
+          <a:p>
+            <a:r>
+              <a:t>Gang affiliation. Cramér's V of 1.0 with gender on the raw field, because it is</a:t>
+            </a:r>
+          </a:p>
+          <a:p>
+            <a:r>
+              <a:t>never recorded for women. It is a measurement artefact about record-keeping, not a</a:t>
+            </a:r>
+          </a:p>
+          <a:p>
+            <a:r>
+              <a:t>behavioural signal about women.</a:t>
+            </a:r>
+          </a:p>
+          <a:p/>
+          <a:p>
+            <a:r>
+              <a:t>Dropping it and re-estimating shrinks the gender FNR gap from -0.10 to about zero</a:t>
+            </a:r>
+          </a:p>
+          <a:p>
+            <a:r>
+              <a:t>for logistic — partly by raising men's FNR, so say that too — at roughly 0.014 AUC</a:t>
+            </a:r>
+          </a:p>
+          <a:p>
+            <a:r>
+              <a:t>and 27 to 41 fewer captured re-arrests. Statistical parity is still rejected.</a:t>
+            </a:r>
+          </a:p>
+        </p:txBody>
+      </p:sp>
+      <p:sp>
+        <p:nvSpPr>
+          <p:cNvPr id="4" name="Slide Number Placeholder 3"/>
+          <p:cNvSpPr>
+            <a:spLocks noGrp="1"/>
+          </p:cNvSpPr>
+          <p:nvPr>
+            <p:ph type="sldNum" idx="5" sz="quarter"/>
+          </p:nvPr>
+        </p:nvSpPr>
+        <p:spPr/>
+      </p:sp>
+    </p:spTree>
+  </p:cSld>
+  <p:clrMapOvr>
+    <a:masterClrMapping/>
+  </p:clrMapOvr>
+</p:notes>
 </file>
 
 <file path=ppt/slideLayouts/slideLayout1.xml><?xml version="1.0" encoding="utf-8"?>
@@ -13591,4 +15553,324 @@
   </a:objectDefaults>
   <a:extraClrSchemeLst/>
 </a:theme>
+</file>
+
+<file path=ppt/theme/theme2.xml><?xml version="1.0" encoding="utf-8"?>
+<a:theme xmlns:a="http://schemas.openxmlformats.org/drawingml/2006/main" name="Office Theme">
+  <a:themeElements>
+    <a:clrScheme name="Office">
+      <a:dk1>
+        <a:sysClr val="windowText" lastClr="000000"/>
+      </a:dk1>
+      <a:lt1>
+        <a:sysClr val="window" lastClr="FFFFFF"/>
+      </a:lt1>
+      <a:dk2>
+        <a:srgbClr val="1F497D"/>
+      </a:dk2>
+      <a:lt2>
+        <a:srgbClr val="EEECE1"/>
+      </a:lt2>
+      <a:accent1>
+        <a:srgbClr val="4F81BD"/>
+      </a:accent1>
+      <a:accent2>
+        <a:srgbClr val="C0504D"/>
+      </a:accent2>
+      <a:accent3>
+        <a:srgbClr val="9BBB59"/>
+      </a:accent3>
+      <a:accent4>
+        <a:srgbClr val="8064A2"/>
+      </a:accent4>
+      <a:accent5>
+        <a:srgbClr val="4BACC6"/>
+      </a:accent5>
+      <a:accent6>
+        <a:srgbClr val="F79646"/>
+      </a:accent6>
+      <a:hlink>
+        <a:srgbClr val="0000FF"/>
+      </a:hlink>
+      <a:folHlink>
+        <a:srgbClr val="800080"/>
+      </a:folHlink>
+    </a:clrScheme>
+    <a:fontScheme name="Office">
+      <a:majorFont>
+        <a:latin typeface="Calibri"/>
+        <a:ea typeface=""/>
+        <a:cs typeface=""/>
+        <a:font script="Jpan" typeface="ＭＳ Ｐゴシック"/>
+        <a:font script="Hang" typeface="맑은 고딕"/>
+        <a:font script="Hans" typeface="宋体"/>
+        <a:font script="Hant" typeface="新細明體"/>
+        <a:font script="Arab" typeface="Times New Roman"/>
+        <a:font script="Hebr" typeface="Times New Roman"/>
+        <a:font script="Thai" typeface="Angsana New"/>
+        <a:font script="Ethi" typeface="Nyala"/>
+        <a:font script="Beng" typeface="Vrinda"/>
+        <a:font script="Gujr" typeface="Shruti"/>
+        <a:font script="Khmr" typeface="MoolBoran"/>
+        <a:font script="Knda" typeface="Tunga"/>
+        <a:font script="Guru" typeface="Raavi"/>
+        <a:font script="Cans" typeface="Euphemia"/>
+        <a:font script="Cher" typeface="Plantagenet Cherokee"/>
+        <a:font script="Yiii" typeface="Microsoft Yi Baiti"/>
+        <a:font script="Tibt" typeface="Microsoft Himalaya"/>
+        <a:font script="Thaa" typeface="MV Boli"/>
+        <a:font script="Deva" typeface="Mangal"/>
+        <a:font script="Telu" typeface="Gautami"/>
+        <a:font script="Taml" typeface="Latha"/>
+        <a:font script="Syrc" typeface="Estrangelo Edessa"/>
+        <a:font script="Orya" typeface="Kalinga"/>
+        <a:font script="Mlym" typeface="Kartika"/>
+        <a:font script="Laoo" typeface="DokChampa"/>
+        <a:font script="Sinh" typeface="Iskoola Pota"/>
+        <a:font script="Mong" typeface="Mongolian Baiti"/>
+        <a:font script="Viet" typeface="Times New Roman"/>
+        <a:font script="Uigh" typeface="Microsoft Uighur"/>
+        <a:font script="Geor" typeface="Sylfaen"/>
+      </a:majorFont>
+      <a:minorFont>
+        <a:latin typeface="Calibri"/>
+        <a:ea typeface=""/>
+        <a:cs typeface=""/>
+        <a:font script="Jpan" typeface="ＭＳ Ｐゴシック"/>
+        <a:font script="Hang" typeface="맑은 고딕"/>
+        <a:font script="Hans" typeface="宋体"/>
+        <a:font script="Hant" typeface="新細明體"/>
+        <a:font script="Arab" typeface="Arial"/>
+        <a:font script="Hebr" typeface="Arial"/>
+        <a:font script="Thai" typeface="Cordia New"/>
+        <a:font script="Ethi" typeface="Nyala"/>
+        <a:font script="Beng" typeface="Vrinda"/>
+        <a:font script="Gujr" typeface="Shruti"/>
+        <a:font script="Khmr" typeface="DaunPenh"/>
+        <a:font script="Knda" typeface="Tunga"/>
+        <a:font script="Guru" typeface="Raavi"/>
+        <a:font script="Cans" typeface="Euphemia"/>
+        <a:font script="Cher" typeface="Plantagenet Cherokee"/>
+        <a:font script="Yiii" typeface="Microsoft Yi Baiti"/>
+        <a:font script="Tibt" typeface="Microsoft Himalaya"/>
+        <a:font script="Thaa" typeface="MV Boli"/>
+        <a:font script="Deva" typeface="Mangal"/>
+        <a:font script="Telu" typeface="Gautami"/>
+        <a:font script="Taml" typeface="Latha"/>
+        <a:font script="Syrc" typeface="Estrangelo Edessa"/>
+        <a:font script="Orya" typeface="Kalinga"/>
+        <a:font script="Mlym" typeface="Kartika"/>
+        <a:font script="Laoo" typeface="DokChampa"/>
+        <a:font script="Sinh" typeface="Iskoola Pota"/>
+        <a:font script="Mong" typeface="Mongolian Baiti"/>
+        <a:font script="Viet" typeface="Arial"/>
+        <a:font script="Uigh" typeface="Microsoft Uighur"/>
+        <a:font script="Geor" typeface="Sylfaen"/>
+      </a:minorFont>
+    </a:fontScheme>
+    <a:fmtScheme name="Office">
+      <a:fillStyleLst>
+        <a:solidFill>
+          <a:schemeClr val="phClr"/>
+        </a:solidFill>
+        <a:gradFill rotWithShape="1">
+          <a:gsLst>
+            <a:gs pos="0">
+              <a:schemeClr val="phClr">
+                <a:tint val="50000"/>
+                <a:satMod val="300000"/>
+              </a:schemeClr>
+            </a:gs>
+            <a:gs pos="35000">
+              <a:schemeClr val="phClr">
+                <a:tint val="37000"/>
+                <a:satMod val="300000"/>
+              </a:schemeClr>
+            </a:gs>
+            <a:gs pos="100000">
+              <a:schemeClr val="phClr">
+                <a:tint val="15000"/>
+                <a:satMod val="350000"/>
+              </a:schemeClr>
+            </a:gs>
+          </a:gsLst>
+          <a:lin ang="16200000" scaled="1"/>
+        </a:gradFill>
+        <a:gradFill rotWithShape="1">
+          <a:gsLst>
+            <a:gs pos="0">
+              <a:schemeClr val="phClr">
+                <a:tint val="100000"/>
+                <a:shade val="100000"/>
+                <a:satMod val="130000"/>
+              </a:schemeClr>
+            </a:gs>
+            <a:gs pos="100000">
+              <a:schemeClr val="phClr">
+                <a:tint val="50000"/>
+                <a:shade val="100000"/>
+                <a:satMod val="350000"/>
+              </a:schemeClr>
+            </a:gs>
+          </a:gsLst>
+          <a:lin ang="16200000" scaled="0"/>
+        </a:gradFill>
+      </a:fillStyleLst>
+      <a:lnStyleLst>
+        <a:ln w="9525" cap="flat" cmpd="sng" algn="ctr">
+          <a:solidFill>
+            <a:schemeClr val="phClr">
+              <a:shade val="95000"/>
+              <a:satMod val="105000"/>
+            </a:schemeClr>
+          </a:solidFill>
+          <a:prstDash val="solid"/>
+        </a:ln>
+        <a:ln w="25400" cap="flat" cmpd="sng" algn="ctr">
+          <a:solidFill>
+            <a:schemeClr val="phClr"/>
+          </a:solidFill>
+          <a:prstDash val="solid"/>
+        </a:ln>
+        <a:ln w="38100" cap="flat" cmpd="sng" algn="ctr">
+          <a:solidFill>
+            <a:schemeClr val="phClr"/>
+          </a:solidFill>
+          <a:prstDash val="solid"/>
+        </a:ln>
+      </a:lnStyleLst>
+      <a:effectStyleLst>
+        <a:effectStyle>
+          <a:effectLst>
+            <a:outerShdw blurRad="40000" dist="20000" dir="5400000" rotWithShape="0">
+              <a:srgbClr val="000000">
+                <a:alpha val="38000"/>
+              </a:srgbClr>
+            </a:outerShdw>
+          </a:effectLst>
+        </a:effectStyle>
+        <a:effectStyle>
+          <a:effectLst>
+            <a:outerShdw blurRad="40000" dist="23000" dir="5400000" rotWithShape="0">
+              <a:srgbClr val="000000">
+                <a:alpha val="35000"/>
+              </a:srgbClr>
+            </a:outerShdw>
+          </a:effectLst>
+        </a:effectStyle>
+        <a:effectStyle>
+          <a:effectLst>
+            <a:outerShdw blurRad="40000" dist="23000" dir="5400000" rotWithShape="0">
+              <a:srgbClr val="000000">
+                <a:alpha val="35000"/>
+              </a:srgbClr>
+            </a:outerShdw>
+          </a:effectLst>
+          <a:scene3d>
+            <a:camera prst="orthographicFront">
+              <a:rot lat="0" lon="0" rev="0"/>
+            </a:camera>
+            <a:lightRig rig="threePt" dir="t">
+              <a:rot lat="0" lon="0" rev="1200000"/>
+            </a:lightRig>
+          </a:scene3d>
+          <a:sp3d>
+            <a:bevelT w="63500" h="25400"/>
+          </a:sp3d>
+        </a:effectStyle>
+      </a:effectStyleLst>
+      <a:bgFillStyleLst>
+        <a:solidFill>
+          <a:schemeClr val="phClr"/>
+        </a:solidFill>
+        <a:gradFill rotWithShape="1">
+          <a:gsLst>
+            <a:gs pos="0">
+              <a:schemeClr val="phClr">
+                <a:tint val="40000"/>
+                <a:satMod val="350000"/>
+              </a:schemeClr>
+            </a:gs>
+            <a:gs pos="40000">
+              <a:schemeClr val="phClr">
+                <a:tint val="45000"/>
+                <a:shade val="99000"/>
+                <a:satMod val="350000"/>
+              </a:schemeClr>
+            </a:gs>
+            <a:gs pos="100000">
+              <a:schemeClr val="phClr">
+                <a:shade val="20000"/>
+                <a:satMod val="255000"/>
+              </a:schemeClr>
+            </a:gs>
+          </a:gsLst>
+          <a:path path="circle">
+            <a:fillToRect l="50000" t="-80000" r="50000" b="180000"/>
+          </a:path>
+        </a:gradFill>
+        <a:gradFill rotWithShape="1">
+          <a:gsLst>
+            <a:gs pos="0">
+              <a:schemeClr val="phClr">
+                <a:tint val="80000"/>
+                <a:satMod val="300000"/>
+              </a:schemeClr>
+            </a:gs>
+            <a:gs pos="100000">
+              <a:schemeClr val="phClr">
+                <a:shade val="30000"/>
+                <a:satMod val="200000"/>
+              </a:schemeClr>
+            </a:gs>
+          </a:gsLst>
+          <a:path path="circle">
+            <a:fillToRect l="50000" t="50000" r="50000" b="50000"/>
+          </a:path>
+        </a:gradFill>
+      </a:bgFillStyleLst>
+    </a:fmtScheme>
+  </a:themeElements>
+  <a:objectDefaults>
+    <a:spDef>
+      <a:spPr/>
+      <a:bodyPr/>
+      <a:lstStyle/>
+      <a:style>
+        <a:lnRef idx="1">
+          <a:schemeClr val="accent1"/>
+        </a:lnRef>
+        <a:fillRef idx="3">
+          <a:schemeClr val="accent1"/>
+        </a:fillRef>
+        <a:effectRef idx="2">
+          <a:schemeClr val="accent1"/>
+        </a:effectRef>
+        <a:fontRef idx="minor">
+          <a:schemeClr val="lt1"/>
+        </a:fontRef>
+      </a:style>
+    </a:spDef>
+    <a:lnDef>
+      <a:spPr/>
+      <a:bodyPr/>
+      <a:lstStyle/>
+      <a:style>
+        <a:lnRef idx="2">
+          <a:schemeClr val="accent1"/>
+        </a:lnRef>
+        <a:fillRef idx="0">
+          <a:schemeClr val="accent1"/>
+        </a:fillRef>
+        <a:effectRef idx="1">
+          <a:schemeClr val="accent1"/>
+        </a:effectRef>
+        <a:fontRef idx="minor">
+          <a:schemeClr val="tx1"/>
+        </a:fontRef>
+      </a:style>
+    </a:lnDef>
+  </a:objectDefaults>
+  <a:extraClrSchemeLst/>
+</a:theme>
 </file>
</xml_diff>